<commit_message>
Session 2: Kahoot before the lab
</commit_message>
<xml_diff>
--- a/instructor/ai-administrator/out/day1/Day1_S2_Prompting_for_Operators.pptx
+++ b/instructor/ai-administrator/out/day1/Day1_S2_Prompting_for_Operators.pptx
@@ -2584,7 +2584,7 @@
           <a:lstStyle/>
           <a:p>
             <a:r>
-              <a:t>Share the handout and the three-column sheet. Most participants will write two or three templates in the room and finish the rest at home. Make sure everyone reaches step 4 at least once so the test-set habit is formed.</a:t>
+              <a:t>Import Day1_S2_Kahoot.xlsx into Kahoot beforehand (Create, then Import spreadsheet). Launch in Classic mode and show the PIN on this slide. Eight minutes covers roughly 15 questions; assign the remainder as a challenge. The answer key with rationales is Day1_S2_Kahoot_Answer_Key.pdf.</a:t>
             </a:r>
           </a:p>
         </p:txBody>
@@ -2654,7 +2654,7 @@
           <a:lstStyle/>
           <a:p>
             <a:r>
-              <a:t>The trap test is the most memorable five minutes of the day. Ask two or three participants to report what their assistant did with the trap questions.</a:t>
+              <a:t>Share the handout and the three-column sheet. Most participants will write two or three templates in the room and finish the rest at home. Make sure everyone reaches step 4 at least once so the test-set habit is formed.</a:t>
             </a:r>
           </a:p>
         </p:txBody>
@@ -2724,7 +2724,7 @@
           <a:lstStyle/>
           <a:p>
             <a:r>
-              <a:t>The point: two assistants, same instructions, same trap questions. The course bot is the reference run; the instructor can show the gateway log while a student asks it something, to make "data goes where the model goes" concrete.</a:t>
+              <a:t>The trap test is the most memorable five minutes of the day. Ask two or three participants to report what their assistant did with the trap questions.</a:t>
             </a:r>
           </a:p>
         </p:txBody>
@@ -2794,7 +2794,7 @@
           <a:lstStyle/>
           <a:p>
             <a:r>
-              <a:t>Point out that the constraints line is pre-filled with the unsure clause. Participants should never remove it.</a:t>
+              <a:t>The point: two assistants, same instructions, same trap questions. The course bot is the reference run; the instructor can show the gateway log while a student asks it something, to make "data goes where the model goes" concrete.</a:t>
             </a:r>
           </a:p>
         </p:txBody>
@@ -2934,7 +2934,7 @@
           <a:lstStyle/>
           <a:p>
             <a:r>
-              <a:t>Demo burst 3 uses exactly this text. Note the three habits inside it: grounded (only from the documents), an exit (not covered), and checkable (quote the sentence).</a:t>
+              <a:t>Point out that the constraints line is pre-filled with the unsure clause. Participants should never remove it.</a:t>
             </a:r>
           </a:p>
         </p:txBody>
@@ -3004,7 +3004,7 @@
           <a:lstStyle/>
           <a:p>
             <a:r>
-              <a:t>The templates are reused on Day 3 inside n8n AI nodes, so quality here saves time later.</a:t>
+              <a:t>Demo burst 3 uses exactly this text. Note the three habits inside it: grounded (only from the documents), an exit (not covered), and checkable (quote the sentence).</a:t>
             </a:r>
           </a:p>
         </p:txBody>
@@ -3074,7 +3074,7 @@
           <a:lstStyle/>
           <a:p>
             <a:r>
-              <a:t>Import Day1_S2_Kahoot.xlsx into Kahoot beforehand (Create, then Import spreadsheet). Launch in Classic mode and show the PIN on this slide. Eight minutes covers roughly 15 questions; assign the remainder as a challenge. The answer key with rationales is Day1_S2_Kahoot_Answer_Key.pdf.</a:t>
+              <a:t>The templates are reused on Day 3 inside n8n AI nodes, so quality here saves time later.</a:t>
             </a:r>
           </a:p>
         </p:txBody>
@@ -16563,7 +16563,7 @@
                           </a:solidFill>
                           <a:latin typeface="Calibri"/>
                         </a:rPr>
-                        <a:t>95 to 112</a:t>
+                        <a:t>95 to 103</a:t>
                       </a:r>
                     </a:p>
                   </a:txBody>
@@ -16585,7 +16585,7 @@
                           </a:solidFill>
                           <a:latin typeface="Calibri"/>
                         </a:rPr>
-                        <a:t>Lab</a:t>
+                        <a:t>Kahoot</a:t>
                       </a:r>
                     </a:p>
                   </a:txBody>
@@ -16607,7 +16607,7 @@
                           </a:solidFill>
                           <a:latin typeface="Calibri"/>
                         </a:rPr>
-                        <a:t>Prompt library, classifier on the live test bench, department assistant, trap test on two assistants</a:t>
+                        <a:t>As many of the 20 questions as time allows; the rest as a challenge link</a:t>
                       </a:r>
                     </a:p>
                   </a:txBody>
@@ -16631,7 +16631,7 @@
                           </a:solidFill>
                           <a:latin typeface="Calibri"/>
                         </a:rPr>
-                        <a:t>112 to 120</a:t>
+                        <a:t>103 to 120</a:t>
                       </a:r>
                     </a:p>
                   </a:txBody>
@@ -16653,7 +16653,7 @@
                           </a:solidFill>
                           <a:latin typeface="Calibri"/>
                         </a:rPr>
-                        <a:t>Kahoot and wrap</a:t>
+                        <a:t>Lab and wrap</a:t>
                       </a:r>
                     </a:p>
                   </a:txBody>
@@ -16675,7 +16675,7 @@
                           </a:solidFill>
                           <a:latin typeface="Calibri"/>
                         </a:rPr>
-                        <a:t>As many of the 20 questions as time allows; the rest as a challenge link; takeaways</a:t>
+                        <a:t>Prompt library, classifier on the live test bench, department assistant, trap test on two assistants; takeaways</a:t>
                       </a:r>
                     </a:p>
                   </a:txBody>
@@ -21722,7 +21722,7 @@
                 </a:solidFill>
                 <a:latin typeface="Calibri"/>
               </a:rPr>
-              <a:t>Practical lab: prompt library and department assistant</a:t>
+              <a:t>Kahoot: knowledge check</a:t>
             </a:r>
           </a:p>
         </p:txBody>
@@ -21757,7 +21757,7 @@
                 </a:solidFill>
                 <a:latin typeface="Calibri"/>
               </a:rPr>
-              <a:t>Steps shown now, finish at home, due before the next session</a:t>
+              <a:t>20 questions, 20 seconds each. Phones out.</a:t>
             </a:r>
           </a:p>
         </p:txBody>
@@ -21792,14 +21792,38 @@
                 </a:solidFill>
                 <a:latin typeface="Calibri"/>
               </a:rPr>
-              <a:t>About 17 minutes</a:t>
-            </a:r>
-          </a:p>
-        </p:txBody>
-      </p:sp>
-      <p:sp>
-        <p:nvSpPr>
-          <p:cNvPr id="7" name="Rectangle 6"/>
+              <a:t>About 8 minutes</a:t>
+            </a:r>
+          </a:p>
+        </p:txBody>
+      </p:sp>
+      <p:pic>
+        <p:nvPicPr>
+          <p:cNvPr id="7" name="Picture 6" descr="kahoot_logo.png"/>
+          <p:cNvPicPr>
+            <a:picLocks noChangeAspect="1"/>
+          </p:cNvPicPr>
+          <p:nvPr/>
+        </p:nvPicPr>
+        <p:blipFill>
+          <a:blip r:embed="rId2"/>
+          <a:stretch>
+            <a:fillRect/>
+          </a:stretch>
+        </p:blipFill>
+        <p:spPr>
+          <a:xfrm>
+            <a:off x="6888175" y="2206219"/>
+            <a:ext cx="4754880" cy="1622602"/>
+          </a:xfrm>
+          <a:prstGeom prst="rect">
+            <a:avLst/>
+          </a:prstGeom>
+        </p:spPr>
+      </p:pic>
+      <p:sp>
+        <p:nvSpPr>
+          <p:cNvPr id="8" name="Rectangle 7"/>
           <p:cNvSpPr/>
           <p:nvPr/>
         </p:nvSpPr>
@@ -21843,7 +21867,7 @@
       </p:sp>
       <p:sp>
         <p:nvSpPr>
-          <p:cNvPr id="8" name="TextBox 7"/>
+          <p:cNvPr id="9" name="TextBox 8"/>
           <p:cNvSpPr txBox="1"/>
           <p:nvPr/>
         </p:nvSpPr>
@@ -21878,7 +21902,7 @@
       </p:sp>
       <p:sp>
         <p:nvSpPr>
-          <p:cNvPr id="9" name="TextBox 8"/>
+          <p:cNvPr id="10" name="TextBox 9"/>
           <p:cNvSpPr txBox="1"/>
           <p:nvPr/>
         </p:nvSpPr>
@@ -21959,7 +21983,7 @@
                 </a:solidFill>
                 <a:latin typeface="Calibri"/>
               </a:rPr>
-              <a:t>Lab steps (1 to 4)</a:t>
+              <a:t>Join the Kahoot</a:t>
             </a:r>
           </a:p>
         </p:txBody>
@@ -22052,18 +22076,77 @@
           </a:p>
         </p:txBody>
       </p:sp>
-      <p:sp>
-        <p:nvSpPr>
-          <p:cNvPr id="5" name="Oval 4"/>
+      <p:pic>
+        <p:nvPicPr>
+          <p:cNvPr id="5" name="Picture 4" descr="kahoot_logo.png"/>
+          <p:cNvPicPr>
+            <a:picLocks noChangeAspect="1"/>
+          </p:cNvPicPr>
+          <p:nvPr/>
+        </p:nvPicPr>
+        <p:blipFill>
+          <a:blip r:embed="rId2"/>
+          <a:stretch>
+            <a:fillRect/>
+          </a:stretch>
+        </p:blipFill>
+        <p:spPr>
+          <a:xfrm>
+            <a:off x="9315522" y="274320"/>
+            <a:ext cx="2277626" cy="777240"/>
+          </a:xfrm>
+          <a:prstGeom prst="rect">
+            <a:avLst/>
+          </a:prstGeom>
+        </p:spPr>
+      </p:pic>
+      <p:sp>
+        <p:nvSpPr>
+          <p:cNvPr id="6" name="TextBox 5"/>
+          <p:cNvSpPr txBox="1"/>
+          <p:nvPr/>
+        </p:nvSpPr>
+        <p:spPr>
+          <a:xfrm>
+            <a:off x="548640" y="1325880"/>
+            <a:ext cx="5318607" cy="457200"/>
+          </a:xfrm>
+          <a:prstGeom prst="rect">
+            <a:avLst/>
+          </a:prstGeom>
+          <a:noFill/>
+        </p:spPr>
+        <p:txBody>
+          <a:bodyPr wrap="square" anchor="t" lIns="45720" rIns="45720" tIns="27432" bIns="27432">
+            <a:spAutoFit/>
+          </a:bodyPr>
+          <a:lstStyle/>
+          <a:p>
+            <a:pPr algn="l"/>
+            <a:r>
+              <a:rPr sz="2000" b="1" i="0">
+                <a:solidFill>
+                  <a:srgbClr val="111111"/>
+                </a:solidFill>
+                <a:latin typeface="Calibri"/>
+              </a:rPr>
+              <a:t>How to join</a:t>
+            </a:r>
+          </a:p>
+        </p:txBody>
+      </p:sp>
+      <p:sp>
+        <p:nvSpPr>
+          <p:cNvPr id="7" name="Rectangle 6"/>
           <p:cNvSpPr/>
           <p:nvPr/>
         </p:nvSpPr>
         <p:spPr>
           <a:xfrm>
-            <a:off x="548640" y="1399032"/>
-            <a:ext cx="384048" cy="384048"/>
-          </a:xfrm>
-          <a:prstGeom prst="ellipse">
+            <a:off x="548640" y="1801368"/>
+            <a:ext cx="5318607" cy="25400"/>
+          </a:xfrm>
+          <a:prstGeom prst="rect">
             <a:avLst/>
           </a:prstGeom>
           <a:solidFill>
@@ -22089,32 +22172,110 @@
           </a:fontRef>
         </p:style>
         <p:txBody>
-          <a:bodyPr rtlCol="0" anchor="ctr" lIns="0" rIns="0"/>
+          <a:bodyPr rtlCol="0" anchor="ctr"/>
           <a:lstStyle/>
           <a:p>
             <a:pPr algn="ctr"/>
-            <a:r>
-              <a:rPr sz="1300" b="1">
-                <a:solidFill>
-                  <a:srgbClr val="FFFFFF"/>
-                </a:solidFill>
-                <a:latin typeface="Calibri"/>
-              </a:rPr>
-              <a:t>1</a:t>
-            </a:r>
-          </a:p>
-        </p:txBody>
-      </p:sp>
-      <p:sp>
-        <p:nvSpPr>
-          <p:cNvPr id="6" name="TextBox 5"/>
+          </a:p>
+        </p:txBody>
+      </p:sp>
+      <p:sp>
+        <p:nvSpPr>
+          <p:cNvPr id="8" name="TextBox 7"/>
           <p:cNvSpPr txBox="1"/>
           <p:nvPr/>
         </p:nvSpPr>
         <p:spPr>
           <a:xfrm>
-            <a:off x="1097280" y="1325880"/>
-            <a:ext cx="10545775" cy="457200"/>
+            <a:off x="548640" y="1920240"/>
+            <a:ext cx="5318607" cy="4297680"/>
+          </a:xfrm>
+          <a:prstGeom prst="rect">
+            <a:avLst/>
+          </a:prstGeom>
+          <a:noFill/>
+        </p:spPr>
+        <p:txBody>
+          <a:bodyPr wrap="square" lIns="45720" rIns="45720">
+            <a:spAutoFit/>
+          </a:bodyPr>
+          <a:lstStyle/>
+          <a:p>
+            <a:pPr>
+              <a:spcAft>
+                <a:spcPts val="1000"/>
+              </a:spcAft>
+            </a:pPr>
+            <a:r>
+              <a:rPr sz="1800">
+                <a:solidFill>
+                  <a:srgbClr val="111111"/>
+                </a:solidFill>
+                <a:latin typeface="Calibri"/>
+              </a:rPr>
+              <a:t>•  Open kahoot.it on your phone, or the Kahoot app</a:t>
+            </a:r>
+          </a:p>
+          <a:p>
+            <a:pPr>
+              <a:spcAft>
+                <a:spcPts val="1000"/>
+              </a:spcAft>
+            </a:pPr>
+            <a:r>
+              <a:rPr sz="1800">
+                <a:solidFill>
+                  <a:srgbClr val="111111"/>
+                </a:solidFill>
+                <a:latin typeface="Calibri"/>
+              </a:rPr>
+              <a:t>•  Enter the game PIN shown on the screen</a:t>
+            </a:r>
+          </a:p>
+          <a:p>
+            <a:pPr>
+              <a:spcAft>
+                <a:spcPts val="1000"/>
+              </a:spcAft>
+            </a:pPr>
+            <a:r>
+              <a:rPr sz="1800">
+                <a:solidFill>
+                  <a:srgbClr val="111111"/>
+                </a:solidFill>
+                <a:latin typeface="Calibri"/>
+              </a:rPr>
+              <a:t>•  Nickname: your first name</a:t>
+            </a:r>
+          </a:p>
+          <a:p>
+            <a:pPr>
+              <a:spcAft>
+                <a:spcPts val="1000"/>
+              </a:spcAft>
+            </a:pPr>
+            <a:r>
+              <a:rPr sz="1800">
+                <a:solidFill>
+                  <a:srgbClr val="111111"/>
+                </a:solidFill>
+                <a:latin typeface="Calibri"/>
+              </a:rPr>
+              <a:t>•  20 seconds per question; answer on your phone</a:t>
+            </a:r>
+          </a:p>
+        </p:txBody>
+      </p:sp>
+      <p:sp>
+        <p:nvSpPr>
+          <p:cNvPr id="9" name="TextBox 8"/>
+          <p:cNvSpPr txBox="1"/>
+          <p:nvPr/>
+        </p:nvSpPr>
+        <p:spPr>
+          <a:xfrm>
+            <a:off x="6324447" y="1325880"/>
+            <a:ext cx="5318607" cy="457200"/>
           </a:xfrm>
           <a:prstGeom prst="rect">
             <a:avLst/>
@@ -22129,27 +22290,71 @@
           <a:p>
             <a:pPr algn="l"/>
             <a:r>
-              <a:rPr sz="1800" b="1" i="0">
+              <a:rPr sz="2000" b="1" i="0">
                 <a:solidFill>
                   <a:srgbClr val="111111"/>
                 </a:solidFill>
                 <a:latin typeface="Calibri"/>
               </a:rPr>
-              <a:t>1. Create the library document</a:t>
-            </a:r>
-          </a:p>
-        </p:txBody>
-      </p:sp>
-      <p:sp>
-        <p:nvSpPr>
-          <p:cNvPr id="7" name="TextBox 6"/>
+              <a:t>Fair play notes</a:t>
+            </a:r>
+          </a:p>
+        </p:txBody>
+      </p:sp>
+      <p:sp>
+        <p:nvSpPr>
+          <p:cNvPr id="10" name="Rectangle 9"/>
+          <p:cNvSpPr/>
+          <p:nvPr/>
+        </p:nvSpPr>
+        <p:spPr>
+          <a:xfrm>
+            <a:off x="6324447" y="1801368"/>
+            <a:ext cx="5318607" cy="25400"/>
+          </a:xfrm>
+          <a:prstGeom prst="rect">
+            <a:avLst/>
+          </a:prstGeom>
+          <a:solidFill>
+            <a:srgbClr val="666666"/>
+          </a:solidFill>
+          <a:ln>
+            <a:noFill/>
+          </a:ln>
+          <a:effectLst/>
+        </p:spPr>
+        <p:style>
+          <a:lnRef idx="1">
+            <a:schemeClr val="accent1"/>
+          </a:lnRef>
+          <a:fillRef idx="3">
+            <a:schemeClr val="accent1"/>
+          </a:fillRef>
+          <a:effectRef idx="2">
+            <a:schemeClr val="accent1"/>
+          </a:effectRef>
+          <a:fontRef idx="minor">
+            <a:schemeClr val="lt1"/>
+          </a:fontRef>
+        </p:style>
+        <p:txBody>
+          <a:bodyPr rtlCol="0" anchor="ctr"/>
+          <a:lstStyle/>
+          <a:p>
+            <a:pPr algn="ctr"/>
+          </a:p>
+        </p:txBody>
+      </p:sp>
+      <p:sp>
+        <p:nvSpPr>
+          <p:cNvPr id="11" name="TextBox 10"/>
           <p:cNvSpPr txBox="1"/>
           <p:nvPr/>
         </p:nvSpPr>
         <p:spPr>
           <a:xfrm>
-            <a:off x="1097280" y="1737360"/>
-            <a:ext cx="10545775" cy="731520"/>
+            <a:off x="6324447" y="1920240"/>
+            <a:ext cx="5318607" cy="4297680"/>
           </a:xfrm>
           <a:prstGeom prst="rect">
             <a:avLst/>
@@ -22157,34 +22362,86 @@
           <a:noFill/>
         </p:spPr>
         <p:txBody>
-          <a:bodyPr wrap="square" anchor="t" lIns="45720" rIns="45720" tIns="27432" bIns="27432">
+          <a:bodyPr wrap="square" lIns="45720" rIns="45720">
             <a:spAutoFit/>
           </a:bodyPr>
           <a:lstStyle/>
           <a:p>
-            <a:pPr algn="l"/>
-            <a:r>
-              <a:rPr sz="1500" b="0" i="0">
+            <a:pPr>
+              <a:spcAft>
+                <a:spcPts val="1000"/>
+              </a:spcAft>
+            </a:pPr>
+            <a:r>
+              <a:rPr sz="1800">
                 <a:solidFill>
                   <a:srgbClr val="111111"/>
                 </a:solidFill>
                 <a:latin typeface="Calibri"/>
               </a:rPr>
-              <a:t>Name it M2-prompt-library. Five headings: Triage an email, Summarise a meeting transcript, Draft a reply, Extract fields from a form, Classify a request.</a:t>
-            </a:r>
-          </a:p>
-        </p:txBody>
-      </p:sp>
-      <p:sp>
-        <p:nvSpPr>
-          <p:cNvPr id="8" name="Rectangle 7"/>
+              <a:t>•  All four answers are about the same length. The long one is not a hint.</a:t>
+            </a:r>
+          </a:p>
+          <a:p>
+            <a:pPr>
+              <a:spcAft>
+                <a:spcPts val="1000"/>
+              </a:spcAft>
+            </a:pPr>
+            <a:r>
+              <a:rPr sz="1800">
+                <a:solidFill>
+                  <a:srgbClr val="111111"/>
+                </a:solidFill>
+                <a:latin typeface="Calibri"/>
+              </a:rPr>
+              <a:t>•  Correct answers are spread evenly over the four colours.</a:t>
+            </a:r>
+          </a:p>
+          <a:p>
+            <a:pPr>
+              <a:spcAft>
+                <a:spcPts val="1000"/>
+              </a:spcAft>
+            </a:pPr>
+            <a:r>
+              <a:rPr sz="1800">
+                <a:solidFill>
+                  <a:srgbClr val="111111"/>
+                </a:solidFill>
+                <a:latin typeface="Calibri"/>
+              </a:rPr>
+              <a:t>•  We run as many as time allows in the room</a:t>
+            </a:r>
+          </a:p>
+          <a:p>
+            <a:pPr>
+              <a:spcAft>
+                <a:spcPts val="1000"/>
+              </a:spcAft>
+            </a:pPr>
+            <a:r>
+              <a:rPr sz="1800">
+                <a:solidFill>
+                  <a:srgbClr val="111111"/>
+                </a:solidFill>
+                <a:latin typeface="Calibri"/>
+              </a:rPr>
+              <a:t>•  The rest arrive as a Kahoot challenge link for homework</a:t>
+            </a:r>
+          </a:p>
+        </p:txBody>
+      </p:sp>
+      <p:sp>
+        <p:nvSpPr>
+          <p:cNvPr id="12" name="Rectangle 11"/>
           <p:cNvSpPr/>
           <p:nvPr/>
         </p:nvSpPr>
         <p:spPr>
           <a:xfrm>
-            <a:off x="1097280" y="2468880"/>
-            <a:ext cx="10545775" cy="19050"/>
+            <a:off x="548640" y="6309360"/>
+            <a:ext cx="11094415" cy="19050"/>
           </a:xfrm>
           <a:prstGeom prst="rect">
             <a:avLst/>
@@ -22221,67 +22478,14 @@
       </p:sp>
       <p:sp>
         <p:nvSpPr>
-          <p:cNvPr id="9" name="Oval 8"/>
-          <p:cNvSpPr/>
-          <p:nvPr/>
-        </p:nvSpPr>
-        <p:spPr>
-          <a:xfrm>
-            <a:off x="548640" y="2587752"/>
-            <a:ext cx="384048" cy="384048"/>
-          </a:xfrm>
-          <a:prstGeom prst="ellipse">
-            <a:avLst/>
-          </a:prstGeom>
-          <a:solidFill>
-            <a:srgbClr val="F7A11A"/>
-          </a:solidFill>
-          <a:ln>
-            <a:noFill/>
-          </a:ln>
-          <a:effectLst/>
-        </p:spPr>
-        <p:style>
-          <a:lnRef idx="1">
-            <a:schemeClr val="accent1"/>
-          </a:lnRef>
-          <a:fillRef idx="3">
-            <a:schemeClr val="accent1"/>
-          </a:fillRef>
-          <a:effectRef idx="2">
-            <a:schemeClr val="accent1"/>
-          </a:effectRef>
-          <a:fontRef idx="minor">
-            <a:schemeClr val="lt1"/>
-          </a:fontRef>
-        </p:style>
-        <p:txBody>
-          <a:bodyPr rtlCol="0" anchor="ctr" lIns="0" rIns="0"/>
-          <a:lstStyle/>
-          <a:p>
-            <a:pPr algn="ctr"/>
-            <a:r>
-              <a:rPr sz="1300" b="1">
-                <a:solidFill>
-                  <a:srgbClr val="FFFFFF"/>
-                </a:solidFill>
-                <a:latin typeface="Calibri"/>
-              </a:rPr>
-              <a:t>2</a:t>
-            </a:r>
-          </a:p>
-        </p:txBody>
-      </p:sp>
-      <p:sp>
-        <p:nvSpPr>
-          <p:cNvPr id="10" name="TextBox 9"/>
+          <p:cNvPr id="13" name="TextBox 12"/>
           <p:cNvSpPr txBox="1"/>
           <p:nvPr/>
         </p:nvSpPr>
         <p:spPr>
           <a:xfrm>
-            <a:off x="1097280" y="2514600"/>
-            <a:ext cx="10545775" cy="457200"/>
+            <a:off x="548640" y="6355080"/>
+            <a:ext cx="9144000" cy="365760"/>
           </a:xfrm>
           <a:prstGeom prst="rect">
             <a:avLst/>
@@ -22296,145 +22500,13 @@
           <a:p>
             <a:pPr algn="l"/>
             <a:r>
-              <a:rPr sz="1800" b="1" i="0">
-                <a:solidFill>
-                  <a:srgbClr val="111111"/>
-                </a:solidFill>
-                <a:latin typeface="Calibri"/>
-              </a:rPr>
-              <a:t>2. Write each template with the five parts</a:t>
-            </a:r>
-          </a:p>
-        </p:txBody>
-      </p:sp>
-      <p:sp>
-        <p:nvSpPr>
-          <p:cNvPr id="11" name="TextBox 10"/>
-          <p:cNvSpPr txBox="1"/>
-          <p:nvPr/>
-        </p:nvSpPr>
-        <p:spPr>
-          <a:xfrm>
-            <a:off x="1097280" y="2926080"/>
-            <a:ext cx="10545775" cy="731520"/>
-          </a:xfrm>
-          <a:prstGeom prst="rect">
-            <a:avLst/>
-          </a:prstGeom>
-          <a:noFill/>
-        </p:spPr>
-        <p:txBody>
-          <a:bodyPr wrap="square" anchor="t" lIns="45720" rIns="45720" tIns="27432" bIns="27432">
-            <a:spAutoFit/>
-          </a:bodyPr>
-          <a:lstStyle/>
-          <a:p>
-            <a:pPr algn="l"/>
-            <a:r>
-              <a:rPr sz="1500" b="0" i="0">
-                <a:solidFill>
-                  <a:srgbClr val="111111"/>
-                </a:solidFill>
-                <a:latin typeface="Calibri"/>
-              </a:rPr>
-              <a:t>Role, context, task, constraints, output format, with [square-bracket] placeholders a colleague can fill in.</a:t>
-            </a:r>
-          </a:p>
-        </p:txBody>
-      </p:sp>
-      <p:sp>
-        <p:nvSpPr>
-          <p:cNvPr id="12" name="Rectangle 11"/>
-          <p:cNvSpPr/>
-          <p:nvPr/>
-        </p:nvSpPr>
-        <p:spPr>
-          <a:xfrm>
-            <a:off x="1097280" y="3657600"/>
-            <a:ext cx="10545775" cy="19050"/>
-          </a:xfrm>
-          <a:prstGeom prst="rect">
-            <a:avLst/>
-          </a:prstGeom>
-          <a:solidFill>
-            <a:srgbClr val="DDDDDD"/>
-          </a:solidFill>
-          <a:ln>
-            <a:noFill/>
-          </a:ln>
-          <a:effectLst/>
-        </p:spPr>
-        <p:style>
-          <a:lnRef idx="1">
-            <a:schemeClr val="accent1"/>
-          </a:lnRef>
-          <a:fillRef idx="3">
-            <a:schemeClr val="accent1"/>
-          </a:fillRef>
-          <a:effectRef idx="2">
-            <a:schemeClr val="accent1"/>
-          </a:effectRef>
-          <a:fontRef idx="minor">
-            <a:schemeClr val="lt1"/>
-          </a:fontRef>
-        </p:style>
-        <p:txBody>
-          <a:bodyPr rtlCol="0" anchor="ctr"/>
-          <a:lstStyle/>
-          <a:p>
-            <a:pPr algn="ctr"/>
-          </a:p>
-        </p:txBody>
-      </p:sp>
-      <p:sp>
-        <p:nvSpPr>
-          <p:cNvPr id="13" name="Oval 12"/>
-          <p:cNvSpPr/>
-          <p:nvPr/>
-        </p:nvSpPr>
-        <p:spPr>
-          <a:xfrm>
-            <a:off x="548640" y="3776472"/>
-            <a:ext cx="384048" cy="384048"/>
-          </a:xfrm>
-          <a:prstGeom prst="ellipse">
-            <a:avLst/>
-          </a:prstGeom>
-          <a:solidFill>
-            <a:srgbClr val="F7A11A"/>
-          </a:solidFill>
-          <a:ln>
-            <a:noFill/>
-          </a:ln>
-          <a:effectLst/>
-        </p:spPr>
-        <p:style>
-          <a:lnRef idx="1">
-            <a:schemeClr val="accent1"/>
-          </a:lnRef>
-          <a:fillRef idx="3">
-            <a:schemeClr val="accent1"/>
-          </a:fillRef>
-          <a:effectRef idx="2">
-            <a:schemeClr val="accent1"/>
-          </a:effectRef>
-          <a:fontRef idx="minor">
-            <a:schemeClr val="lt1"/>
-          </a:fontRef>
-        </p:style>
-        <p:txBody>
-          <a:bodyPr rtlCol="0" anchor="ctr" lIns="0" rIns="0"/>
-          <a:lstStyle/>
-          <a:p>
-            <a:pPr algn="ctr"/>
-            <a:r>
-              <a:rPr sz="1300" b="1">
-                <a:solidFill>
-                  <a:srgbClr val="FFFFFF"/>
-                </a:solidFill>
-                <a:latin typeface="Calibri"/>
-              </a:rPr>
-              <a:t>3</a:t>
+              <a:rPr sz="1000" b="0" i="0">
+                <a:solidFill>
+                  <a:srgbClr val="666666"/>
+                </a:solidFill>
+                <a:latin typeface="Calibri"/>
+              </a:rPr>
+              <a:t>IEEE CS Region 8 AI Caravan 2026 · AI Administrator · Day 1 · Session 2</a:t>
             </a:r>
           </a:p>
         </p:txBody>
@@ -22442,322 +22514,6 @@
       <p:sp>
         <p:nvSpPr>
           <p:cNvPr id="14" name="TextBox 13"/>
-          <p:cNvSpPr txBox="1"/>
-          <p:nvPr/>
-        </p:nvSpPr>
-        <p:spPr>
-          <a:xfrm>
-            <a:off x="1097280" y="3703320"/>
-            <a:ext cx="10545775" cy="457200"/>
-          </a:xfrm>
-          <a:prstGeom prst="rect">
-            <a:avLst/>
-          </a:prstGeom>
-          <a:noFill/>
-        </p:spPr>
-        <p:txBody>
-          <a:bodyPr wrap="square" anchor="t" lIns="45720" rIns="45720" tIns="27432" bIns="27432">
-            <a:spAutoFit/>
-          </a:bodyPr>
-          <a:lstStyle/>
-          <a:p>
-            <a:pPr algn="l"/>
-            <a:r>
-              <a:rPr sz="1800" b="1" i="0">
-                <a:solidFill>
-                  <a:srgbClr val="111111"/>
-                </a:solidFill>
-                <a:latin typeface="Calibri"/>
-              </a:rPr>
-              <a:t>3. Add examples to the classifier</a:t>
-            </a:r>
-          </a:p>
-        </p:txBody>
-      </p:sp>
-      <p:sp>
-        <p:nvSpPr>
-          <p:cNvPr id="15" name="TextBox 14"/>
-          <p:cNvSpPr txBox="1"/>
-          <p:nvPr/>
-        </p:nvSpPr>
-        <p:spPr>
-          <a:xfrm>
-            <a:off x="1097280" y="4114800"/>
-            <a:ext cx="10545775" cy="731520"/>
-          </a:xfrm>
-          <a:prstGeom prst="rect">
-            <a:avLst/>
-          </a:prstGeom>
-          <a:noFill/>
-        </p:spPr>
-        <p:txBody>
-          <a:bodyPr wrap="square" anchor="t" lIns="45720" rIns="45720" tIns="27432" bIns="27432">
-            <a:spAutoFit/>
-          </a:bodyPr>
-          <a:lstStyle/>
-          <a:p>
-            <a:pPr algn="l"/>
-            <a:r>
-              <a:rPr sz="1500" b="0" i="0">
-                <a:solidFill>
-                  <a:srgbClr val="111111"/>
-                </a:solidFill>
-                <a:latin typeface="Calibri"/>
-              </a:rPr>
-              <a:t>Four allowed categories, one example each, plus a fifth awkward example that should be 'other'.</a:t>
-            </a:r>
-          </a:p>
-        </p:txBody>
-      </p:sp>
-      <p:sp>
-        <p:nvSpPr>
-          <p:cNvPr id="16" name="Rectangle 15"/>
-          <p:cNvSpPr/>
-          <p:nvPr/>
-        </p:nvSpPr>
-        <p:spPr>
-          <a:xfrm>
-            <a:off x="1097280" y="4846320"/>
-            <a:ext cx="10545775" cy="19050"/>
-          </a:xfrm>
-          <a:prstGeom prst="rect">
-            <a:avLst/>
-          </a:prstGeom>
-          <a:solidFill>
-            <a:srgbClr val="DDDDDD"/>
-          </a:solidFill>
-          <a:ln>
-            <a:noFill/>
-          </a:ln>
-          <a:effectLst/>
-        </p:spPr>
-        <p:style>
-          <a:lnRef idx="1">
-            <a:schemeClr val="accent1"/>
-          </a:lnRef>
-          <a:fillRef idx="3">
-            <a:schemeClr val="accent1"/>
-          </a:fillRef>
-          <a:effectRef idx="2">
-            <a:schemeClr val="accent1"/>
-          </a:effectRef>
-          <a:fontRef idx="minor">
-            <a:schemeClr val="lt1"/>
-          </a:fontRef>
-        </p:style>
-        <p:txBody>
-          <a:bodyPr rtlCol="0" anchor="ctr"/>
-          <a:lstStyle/>
-          <a:p>
-            <a:pPr algn="ctr"/>
-          </a:p>
-        </p:txBody>
-      </p:sp>
-      <p:sp>
-        <p:nvSpPr>
-          <p:cNvPr id="17" name="Oval 16"/>
-          <p:cNvSpPr/>
-          <p:nvPr/>
-        </p:nvSpPr>
-        <p:spPr>
-          <a:xfrm>
-            <a:off x="548640" y="4965192"/>
-            <a:ext cx="384048" cy="384048"/>
-          </a:xfrm>
-          <a:prstGeom prst="ellipse">
-            <a:avLst/>
-          </a:prstGeom>
-          <a:solidFill>
-            <a:srgbClr val="F7A11A"/>
-          </a:solidFill>
-          <a:ln>
-            <a:noFill/>
-          </a:ln>
-          <a:effectLst/>
-        </p:spPr>
-        <p:style>
-          <a:lnRef idx="1">
-            <a:schemeClr val="accent1"/>
-          </a:lnRef>
-          <a:fillRef idx="3">
-            <a:schemeClr val="accent1"/>
-          </a:fillRef>
-          <a:effectRef idx="2">
-            <a:schemeClr val="accent1"/>
-          </a:effectRef>
-          <a:fontRef idx="minor">
-            <a:schemeClr val="lt1"/>
-          </a:fontRef>
-        </p:style>
-        <p:txBody>
-          <a:bodyPr rtlCol="0" anchor="ctr" lIns="0" rIns="0"/>
-          <a:lstStyle/>
-          <a:p>
-            <a:pPr algn="ctr"/>
-            <a:r>
-              <a:rPr sz="1300" b="1">
-                <a:solidFill>
-                  <a:srgbClr val="FFFFFF"/>
-                </a:solidFill>
-                <a:latin typeface="Calibri"/>
-              </a:rPr>
-              <a:t>4</a:t>
-            </a:r>
-          </a:p>
-        </p:txBody>
-      </p:sp>
-      <p:sp>
-        <p:nvSpPr>
-          <p:cNvPr id="18" name="TextBox 17"/>
-          <p:cNvSpPr txBox="1"/>
-          <p:nvPr/>
-        </p:nvSpPr>
-        <p:spPr>
-          <a:xfrm>
-            <a:off x="1097280" y="4892040"/>
-            <a:ext cx="10545775" cy="457200"/>
-          </a:xfrm>
-          <a:prstGeom prst="rect">
-            <a:avLst/>
-          </a:prstGeom>
-          <a:noFill/>
-        </p:spPr>
-        <p:txBody>
-          <a:bodyPr wrap="square" anchor="t" lIns="45720" rIns="45720" tIns="27432" bIns="27432">
-            <a:spAutoFit/>
-          </a:bodyPr>
-          <a:lstStyle/>
-          <a:p>
-            <a:pPr algn="l"/>
-            <a:r>
-              <a:rPr sz="1800" b="1" i="0">
-                <a:solidFill>
-                  <a:srgbClr val="111111"/>
-                </a:solidFill>
-                <a:latin typeface="Calibri"/>
-              </a:rPr>
-              <a:t>4. Build the ten-row test set</a:t>
-            </a:r>
-          </a:p>
-        </p:txBody>
-      </p:sp>
-      <p:sp>
-        <p:nvSpPr>
-          <p:cNvPr id="19" name="TextBox 18"/>
-          <p:cNvSpPr txBox="1"/>
-          <p:nvPr/>
-        </p:nvSpPr>
-        <p:spPr>
-          <a:xfrm>
-            <a:off x="1097280" y="5303520"/>
-            <a:ext cx="10545775" cy="731520"/>
-          </a:xfrm>
-          <a:prstGeom prst="rect">
-            <a:avLst/>
-          </a:prstGeom>
-          <a:noFill/>
-        </p:spPr>
-        <p:txBody>
-          <a:bodyPr wrap="square" anchor="t" lIns="45720" rIns="45720" tIns="27432" bIns="27432">
-            <a:spAutoFit/>
-          </a:bodyPr>
-          <a:lstStyle/>
-          <a:p>
-            <a:pPr algn="l"/>
-            <a:r>
-              <a:rPr sz="1500" b="0" i="0">
-                <a:solidFill>
-                  <a:srgbClr val="111111"/>
-                </a:solidFill>
-                <a:latin typeface="Calibri"/>
-              </a:rPr>
-              <a:t>Ten realistic inputs with the expected category; run the prompt; record the model's answer; count matches.</a:t>
-            </a:r>
-          </a:p>
-        </p:txBody>
-      </p:sp>
-      <p:sp>
-        <p:nvSpPr>
-          <p:cNvPr id="20" name="Rectangle 19"/>
-          <p:cNvSpPr/>
-          <p:nvPr/>
-        </p:nvSpPr>
-        <p:spPr>
-          <a:xfrm>
-            <a:off x="548640" y="6309360"/>
-            <a:ext cx="11094415" cy="19050"/>
-          </a:xfrm>
-          <a:prstGeom prst="rect">
-            <a:avLst/>
-          </a:prstGeom>
-          <a:solidFill>
-            <a:srgbClr val="DDDDDD"/>
-          </a:solidFill>
-          <a:ln>
-            <a:noFill/>
-          </a:ln>
-          <a:effectLst/>
-        </p:spPr>
-        <p:style>
-          <a:lnRef idx="1">
-            <a:schemeClr val="accent1"/>
-          </a:lnRef>
-          <a:fillRef idx="3">
-            <a:schemeClr val="accent1"/>
-          </a:fillRef>
-          <a:effectRef idx="2">
-            <a:schemeClr val="accent1"/>
-          </a:effectRef>
-          <a:fontRef idx="minor">
-            <a:schemeClr val="lt1"/>
-          </a:fontRef>
-        </p:style>
-        <p:txBody>
-          <a:bodyPr rtlCol="0" anchor="ctr"/>
-          <a:lstStyle/>
-          <a:p>
-            <a:pPr algn="ctr"/>
-          </a:p>
-        </p:txBody>
-      </p:sp>
-      <p:sp>
-        <p:nvSpPr>
-          <p:cNvPr id="21" name="TextBox 20"/>
-          <p:cNvSpPr txBox="1"/>
-          <p:nvPr/>
-        </p:nvSpPr>
-        <p:spPr>
-          <a:xfrm>
-            <a:off x="548640" y="6355080"/>
-            <a:ext cx="9144000" cy="365760"/>
-          </a:xfrm>
-          <a:prstGeom prst="rect">
-            <a:avLst/>
-          </a:prstGeom>
-          <a:noFill/>
-        </p:spPr>
-        <p:txBody>
-          <a:bodyPr wrap="square" anchor="t" lIns="45720" rIns="45720" tIns="27432" bIns="27432">
-            <a:spAutoFit/>
-          </a:bodyPr>
-          <a:lstStyle/>
-          <a:p>
-            <a:pPr algn="l"/>
-            <a:r>
-              <a:rPr sz="1000" b="0" i="0">
-                <a:solidFill>
-                  <a:srgbClr val="666666"/>
-                </a:solidFill>
-                <a:latin typeface="Calibri"/>
-              </a:rPr>
-              <a:t>IEEE CS Region 8 AI Caravan 2026 · AI Administrator · Day 1 · Session 2</a:t>
-            </a:r>
-          </a:p>
-        </p:txBody>
-      </p:sp>
-      <p:sp>
-        <p:nvSpPr>
-          <p:cNvPr id="22" name="TextBox 21"/>
           <p:cNvSpPr txBox="1"/>
           <p:nvPr/>
         </p:nvSpPr>
@@ -22816,8 +22572,8 @@
         </p:nvSpPr>
         <p:spPr>
           <a:xfrm>
-            <a:off x="548640" y="365760"/>
-            <a:ext cx="11094415" cy="777240"/>
+            <a:off x="548640" y="2011680"/>
+            <a:ext cx="11094415" cy="457200"/>
           </a:xfrm>
           <a:prstGeom prst="rect">
             <a:avLst/>
@@ -22825,20 +22581,20 @@
           <a:noFill/>
         </p:spPr>
         <p:txBody>
-          <a:bodyPr wrap="square" anchor="b" lIns="45720" rIns="45720" tIns="27432" bIns="27432">
+          <a:bodyPr wrap="square" anchor="t" lIns="45720" rIns="45720" tIns="27432" bIns="27432">
             <a:spAutoFit/>
           </a:bodyPr>
           <a:lstStyle/>
           <a:p>
             <a:pPr algn="l"/>
             <a:r>
-              <a:rPr sz="3000" b="1" i="0">
-                <a:solidFill>
-                  <a:srgbClr val="111111"/>
-                </a:solidFill>
-                <a:latin typeface="Calibri"/>
-              </a:rPr>
-              <a:t>Lab steps (5 to 7)</a:t>
+              <a:rPr sz="1400" b="0" i="0">
+                <a:solidFill>
+                  <a:srgbClr val="666666"/>
+                </a:solidFill>
+                <a:latin typeface="Calibri"/>
+              </a:rPr>
+              <a:t>Section · minute 103</a:t>
             </a:r>
           </a:p>
         </p:txBody>
@@ -22851,8 +22607,8 @@
         </p:nvSpPr>
         <p:spPr>
           <a:xfrm>
-            <a:off x="548640" y="1115568"/>
-            <a:ext cx="1097280" cy="38100"/>
+            <a:off x="548640" y="2514600"/>
+            <a:ext cx="1463040" cy="50800"/>
           </a:xfrm>
           <a:prstGeom prst="rect">
             <a:avLst/>
@@ -22889,14 +22645,119 @@
       </p:sp>
       <p:sp>
         <p:nvSpPr>
-          <p:cNvPr id="4" name="Rectangle 3"/>
+          <p:cNvPr id="4" name="TextBox 3"/>
+          <p:cNvSpPr txBox="1"/>
+          <p:nvPr/>
+        </p:nvSpPr>
+        <p:spPr>
+          <a:xfrm>
+            <a:off x="548640" y="2651760"/>
+            <a:ext cx="11094415" cy="1371600"/>
+          </a:xfrm>
+          <a:prstGeom prst="rect">
+            <a:avLst/>
+          </a:prstGeom>
+          <a:noFill/>
+        </p:spPr>
+        <p:txBody>
+          <a:bodyPr wrap="square" anchor="t" lIns="45720" rIns="45720" tIns="27432" bIns="27432">
+            <a:spAutoFit/>
+          </a:bodyPr>
+          <a:lstStyle/>
+          <a:p>
+            <a:pPr algn="l"/>
+            <a:r>
+              <a:rPr sz="3800" b="1" i="0">
+                <a:solidFill>
+                  <a:srgbClr val="111111"/>
+                </a:solidFill>
+                <a:latin typeface="Calibri"/>
+              </a:rPr>
+              <a:t>Practical lab: prompt library and department assistant</a:t>
+            </a:r>
+          </a:p>
+        </p:txBody>
+      </p:sp>
+      <p:sp>
+        <p:nvSpPr>
+          <p:cNvPr id="5" name="TextBox 4"/>
+          <p:cNvSpPr txBox="1"/>
+          <p:nvPr/>
+        </p:nvSpPr>
+        <p:spPr>
+          <a:xfrm>
+            <a:off x="548640" y="4023360"/>
+            <a:ext cx="11094415" cy="822960"/>
+          </a:xfrm>
+          <a:prstGeom prst="rect">
+            <a:avLst/>
+          </a:prstGeom>
+          <a:noFill/>
+        </p:spPr>
+        <p:txBody>
+          <a:bodyPr wrap="square" anchor="t" lIns="45720" rIns="45720" tIns="27432" bIns="27432">
+            <a:spAutoFit/>
+          </a:bodyPr>
+          <a:lstStyle/>
+          <a:p>
+            <a:pPr algn="l"/>
+            <a:r>
+              <a:rPr sz="2000" b="0" i="0">
+                <a:solidFill>
+                  <a:srgbClr val="666666"/>
+                </a:solidFill>
+                <a:latin typeface="Calibri"/>
+              </a:rPr>
+              <a:t>Steps shown now, finish at home, due before the next session</a:t>
+            </a:r>
+          </a:p>
+        </p:txBody>
+      </p:sp>
+      <p:sp>
+        <p:nvSpPr>
+          <p:cNvPr id="6" name="TextBox 5"/>
+          <p:cNvSpPr txBox="1"/>
+          <p:nvPr/>
+        </p:nvSpPr>
+        <p:spPr>
+          <a:xfrm>
+            <a:off x="548640" y="4846320"/>
+            <a:ext cx="11094415" cy="457200"/>
+          </a:xfrm>
+          <a:prstGeom prst="rect">
+            <a:avLst/>
+          </a:prstGeom>
+          <a:noFill/>
+        </p:spPr>
+        <p:txBody>
+          <a:bodyPr wrap="square" anchor="t" lIns="45720" rIns="45720" tIns="27432" bIns="27432">
+            <a:spAutoFit/>
+          </a:bodyPr>
+          <a:lstStyle/>
+          <a:p>
+            <a:pPr algn="l"/>
+            <a:r>
+              <a:rPr sz="1400" b="0" i="0">
+                <a:solidFill>
+                  <a:srgbClr val="666666"/>
+                </a:solidFill>
+                <a:latin typeface="Calibri"/>
+              </a:rPr>
+              <a:t>About 17 minutes</a:t>
+            </a:r>
+          </a:p>
+        </p:txBody>
+      </p:sp>
+      <p:sp>
+        <p:nvSpPr>
+          <p:cNvPr id="7" name="Rectangle 6"/>
           <p:cNvSpPr/>
           <p:nvPr/>
         </p:nvSpPr>
         <p:spPr>
           <a:xfrm>
-            <a:off x="1645920" y="1115568"/>
-            <a:ext cx="9997135" cy="19050"/>
+            <a:off x="548640" y="6309360"/>
+            <a:ext cx="11094415" cy="19050"/>
           </a:xfrm>
           <a:prstGeom prst="rect">
             <a:avLst/>
@@ -22933,67 +22794,14 @@
       </p:sp>
       <p:sp>
         <p:nvSpPr>
-          <p:cNvPr id="5" name="Oval 4"/>
-          <p:cNvSpPr/>
-          <p:nvPr/>
-        </p:nvSpPr>
-        <p:spPr>
-          <a:xfrm>
-            <a:off x="548640" y="1399032"/>
-            <a:ext cx="384048" cy="384048"/>
-          </a:xfrm>
-          <a:prstGeom prst="ellipse">
-            <a:avLst/>
-          </a:prstGeom>
-          <a:solidFill>
-            <a:srgbClr val="F7A11A"/>
-          </a:solidFill>
-          <a:ln>
-            <a:noFill/>
-          </a:ln>
-          <a:effectLst/>
-        </p:spPr>
-        <p:style>
-          <a:lnRef idx="1">
-            <a:schemeClr val="accent1"/>
-          </a:lnRef>
-          <a:fillRef idx="3">
-            <a:schemeClr val="accent1"/>
-          </a:fillRef>
-          <a:effectRef idx="2">
-            <a:schemeClr val="accent1"/>
-          </a:effectRef>
-          <a:fontRef idx="minor">
-            <a:schemeClr val="lt1"/>
-          </a:fontRef>
-        </p:style>
-        <p:txBody>
-          <a:bodyPr rtlCol="0" anchor="ctr" lIns="0" rIns="0"/>
-          <a:lstStyle/>
-          <a:p>
-            <a:pPr algn="ctr"/>
-            <a:r>
-              <a:rPr sz="1300" b="1">
-                <a:solidFill>
-                  <a:srgbClr val="FFFFFF"/>
-                </a:solidFill>
-                <a:latin typeface="Calibri"/>
-              </a:rPr>
-              <a:t>1</a:t>
-            </a:r>
-          </a:p>
-        </p:txBody>
-      </p:sp>
-      <p:sp>
-        <p:nvSpPr>
-          <p:cNvPr id="6" name="TextBox 5"/>
+          <p:cNvPr id="8" name="TextBox 7"/>
           <p:cNvSpPr txBox="1"/>
           <p:nvPr/>
         </p:nvSpPr>
         <p:spPr>
           <a:xfrm>
-            <a:off x="1097280" y="1325880"/>
-            <a:ext cx="10545775" cy="457200"/>
+            <a:off x="548640" y="6355080"/>
+            <a:ext cx="9144000" cy="365760"/>
           </a:xfrm>
           <a:prstGeom prst="rect">
             <a:avLst/>
@@ -23008,454 +22816,6 @@
           <a:p>
             <a:pPr algn="l"/>
             <a:r>
-              <a:rPr sz="1800" b="1" i="0">
-                <a:solidFill>
-                  <a:srgbClr val="111111"/>
-                </a:solidFill>
-                <a:latin typeface="Calibri"/>
-              </a:rPr>
-              <a:t>5. Fix and re-run</a:t>
-            </a:r>
-          </a:p>
-        </p:txBody>
-      </p:sp>
-      <p:sp>
-        <p:nvSpPr>
-          <p:cNvPr id="7" name="TextBox 6"/>
-          <p:cNvSpPr txBox="1"/>
-          <p:nvPr/>
-        </p:nvSpPr>
-        <p:spPr>
-          <a:xfrm>
-            <a:off x="1097280" y="1737360"/>
-            <a:ext cx="10545775" cy="1127760"/>
-          </a:xfrm>
-          <a:prstGeom prst="rect">
-            <a:avLst/>
-          </a:prstGeom>
-          <a:noFill/>
-        </p:spPr>
-        <p:txBody>
-          <a:bodyPr wrap="square" anchor="t" lIns="45720" rIns="45720" tIns="27432" bIns="27432">
-            <a:spAutoFit/>
-          </a:bodyPr>
-          <a:lstStyle/>
-          <a:p>
-            <a:pPr algn="l"/>
-            <a:r>
-              <a:rPr sz="1500" b="0" i="0">
-                <a:solidFill>
-                  <a:srgbClr val="111111"/>
-                </a:solidFill>
-                <a:latin typeface="Calibri"/>
-              </a:rPr>
-              <a:t>For every mismatch, change the prompt (a constraint or an example) and run all ten again. Record the second score.</a:t>
-            </a:r>
-          </a:p>
-        </p:txBody>
-      </p:sp>
-      <p:sp>
-        <p:nvSpPr>
-          <p:cNvPr id="8" name="Rectangle 7"/>
-          <p:cNvSpPr/>
-          <p:nvPr/>
-        </p:nvSpPr>
-        <p:spPr>
-          <a:xfrm>
-            <a:off x="1097280" y="2865120"/>
-            <a:ext cx="10545775" cy="19050"/>
-          </a:xfrm>
-          <a:prstGeom prst="rect">
-            <a:avLst/>
-          </a:prstGeom>
-          <a:solidFill>
-            <a:srgbClr val="DDDDDD"/>
-          </a:solidFill>
-          <a:ln>
-            <a:noFill/>
-          </a:ln>
-          <a:effectLst/>
-        </p:spPr>
-        <p:style>
-          <a:lnRef idx="1">
-            <a:schemeClr val="accent1"/>
-          </a:lnRef>
-          <a:fillRef idx="3">
-            <a:schemeClr val="accent1"/>
-          </a:fillRef>
-          <a:effectRef idx="2">
-            <a:schemeClr val="accent1"/>
-          </a:effectRef>
-          <a:fontRef idx="minor">
-            <a:schemeClr val="lt1"/>
-          </a:fontRef>
-        </p:style>
-        <p:txBody>
-          <a:bodyPr rtlCol="0" anchor="ctr"/>
-          <a:lstStyle/>
-          <a:p>
-            <a:pPr algn="ctr"/>
-          </a:p>
-        </p:txBody>
-      </p:sp>
-      <p:sp>
-        <p:nvSpPr>
-          <p:cNvPr id="9" name="Oval 8"/>
-          <p:cNvSpPr/>
-          <p:nvPr/>
-        </p:nvSpPr>
-        <p:spPr>
-          <a:xfrm>
-            <a:off x="548640" y="2983992"/>
-            <a:ext cx="384048" cy="384048"/>
-          </a:xfrm>
-          <a:prstGeom prst="ellipse">
-            <a:avLst/>
-          </a:prstGeom>
-          <a:solidFill>
-            <a:srgbClr val="F7A11A"/>
-          </a:solidFill>
-          <a:ln>
-            <a:noFill/>
-          </a:ln>
-          <a:effectLst/>
-        </p:spPr>
-        <p:style>
-          <a:lnRef idx="1">
-            <a:schemeClr val="accent1"/>
-          </a:lnRef>
-          <a:fillRef idx="3">
-            <a:schemeClr val="accent1"/>
-          </a:fillRef>
-          <a:effectRef idx="2">
-            <a:schemeClr val="accent1"/>
-          </a:effectRef>
-          <a:fontRef idx="minor">
-            <a:schemeClr val="lt1"/>
-          </a:fontRef>
-        </p:style>
-        <p:txBody>
-          <a:bodyPr rtlCol="0" anchor="ctr" lIns="0" rIns="0"/>
-          <a:lstStyle/>
-          <a:p>
-            <a:pPr algn="ctr"/>
-            <a:r>
-              <a:rPr sz="1300" b="1">
-                <a:solidFill>
-                  <a:srgbClr val="FFFFFF"/>
-                </a:solidFill>
-                <a:latin typeface="Calibri"/>
-              </a:rPr>
-              <a:t>2</a:t>
-            </a:r>
-          </a:p>
-        </p:txBody>
-      </p:sp>
-      <p:sp>
-        <p:nvSpPr>
-          <p:cNvPr id="10" name="TextBox 9"/>
-          <p:cNvSpPr txBox="1"/>
-          <p:nvPr/>
-        </p:nvSpPr>
-        <p:spPr>
-          <a:xfrm>
-            <a:off x="1097280" y="2910840"/>
-            <a:ext cx="10545775" cy="457200"/>
-          </a:xfrm>
-          <a:prstGeom prst="rect">
-            <a:avLst/>
-          </a:prstGeom>
-          <a:noFill/>
-        </p:spPr>
-        <p:txBody>
-          <a:bodyPr wrap="square" anchor="t" lIns="45720" rIns="45720" tIns="27432" bIns="27432">
-            <a:spAutoFit/>
-          </a:bodyPr>
-          <a:lstStyle/>
-          <a:p>
-            <a:pPr algn="l"/>
-            <a:r>
-              <a:rPr sz="1800" b="1" i="0">
-                <a:solidFill>
-                  <a:srgbClr val="111111"/>
-                </a:solidFill>
-                <a:latin typeface="Calibri"/>
-              </a:rPr>
-              <a:t>6. Create the department assistant</a:t>
-            </a:r>
-          </a:p>
-        </p:txBody>
-      </p:sp>
-      <p:sp>
-        <p:nvSpPr>
-          <p:cNvPr id="11" name="TextBox 10"/>
-          <p:cNvSpPr txBox="1"/>
-          <p:nvPr/>
-        </p:nvSpPr>
-        <p:spPr>
-          <a:xfrm>
-            <a:off x="1097280" y="3322320"/>
-            <a:ext cx="10545775" cy="1127760"/>
-          </a:xfrm>
-          <a:prstGeom prst="rect">
-            <a:avLst/>
-          </a:prstGeom>
-          <a:noFill/>
-        </p:spPr>
-        <p:txBody>
-          <a:bodyPr wrap="square" anchor="t" lIns="45720" rIns="45720" tIns="27432" bIns="27432">
-            <a:spAutoFit/>
-          </a:bodyPr>
-          <a:lstStyle/>
-          <a:p>
-            <a:pPr algn="l"/>
-            <a:r>
-              <a:rPr sz="1500" b="0" i="0">
-                <a:solidFill>
-                  <a:srgbClr val="111111"/>
-                </a:solidFill>
-                <a:latin typeface="Calibri"/>
-              </a:rPr>
-              <a:t>A Project, custom GPT, Gem or Copilot agent. Paste the instructions on the next slide; upload two public policy documents.</a:t>
-            </a:r>
-          </a:p>
-        </p:txBody>
-      </p:sp>
-      <p:sp>
-        <p:nvSpPr>
-          <p:cNvPr id="12" name="Rectangle 11"/>
-          <p:cNvSpPr/>
-          <p:nvPr/>
-        </p:nvSpPr>
-        <p:spPr>
-          <a:xfrm>
-            <a:off x="1097280" y="4450080"/>
-            <a:ext cx="10545775" cy="19050"/>
-          </a:xfrm>
-          <a:prstGeom prst="rect">
-            <a:avLst/>
-          </a:prstGeom>
-          <a:solidFill>
-            <a:srgbClr val="DDDDDD"/>
-          </a:solidFill>
-          <a:ln>
-            <a:noFill/>
-          </a:ln>
-          <a:effectLst/>
-        </p:spPr>
-        <p:style>
-          <a:lnRef idx="1">
-            <a:schemeClr val="accent1"/>
-          </a:lnRef>
-          <a:fillRef idx="3">
-            <a:schemeClr val="accent1"/>
-          </a:fillRef>
-          <a:effectRef idx="2">
-            <a:schemeClr val="accent1"/>
-          </a:effectRef>
-          <a:fontRef idx="minor">
-            <a:schemeClr val="lt1"/>
-          </a:fontRef>
-        </p:style>
-        <p:txBody>
-          <a:bodyPr rtlCol="0" anchor="ctr"/>
-          <a:lstStyle/>
-          <a:p>
-            <a:pPr algn="ctr"/>
-          </a:p>
-        </p:txBody>
-      </p:sp>
-      <p:sp>
-        <p:nvSpPr>
-          <p:cNvPr id="13" name="Oval 12"/>
-          <p:cNvSpPr/>
-          <p:nvPr/>
-        </p:nvSpPr>
-        <p:spPr>
-          <a:xfrm>
-            <a:off x="548640" y="4568952"/>
-            <a:ext cx="384048" cy="384048"/>
-          </a:xfrm>
-          <a:prstGeom prst="ellipse">
-            <a:avLst/>
-          </a:prstGeom>
-          <a:solidFill>
-            <a:srgbClr val="F7A11A"/>
-          </a:solidFill>
-          <a:ln>
-            <a:noFill/>
-          </a:ln>
-          <a:effectLst/>
-        </p:spPr>
-        <p:style>
-          <a:lnRef idx="1">
-            <a:schemeClr val="accent1"/>
-          </a:lnRef>
-          <a:fillRef idx="3">
-            <a:schemeClr val="accent1"/>
-          </a:fillRef>
-          <a:effectRef idx="2">
-            <a:schemeClr val="accent1"/>
-          </a:effectRef>
-          <a:fontRef idx="minor">
-            <a:schemeClr val="lt1"/>
-          </a:fontRef>
-        </p:style>
-        <p:txBody>
-          <a:bodyPr rtlCol="0" anchor="ctr" lIns="0" rIns="0"/>
-          <a:lstStyle/>
-          <a:p>
-            <a:pPr algn="ctr"/>
-            <a:r>
-              <a:rPr sz="1300" b="1">
-                <a:solidFill>
-                  <a:srgbClr val="FFFFFF"/>
-                </a:solidFill>
-                <a:latin typeface="Calibri"/>
-              </a:rPr>
-              <a:t>3</a:t>
-            </a:r>
-          </a:p>
-        </p:txBody>
-      </p:sp>
-      <p:sp>
-        <p:nvSpPr>
-          <p:cNvPr id="14" name="TextBox 13"/>
-          <p:cNvSpPr txBox="1"/>
-          <p:nvPr/>
-        </p:nvSpPr>
-        <p:spPr>
-          <a:xfrm>
-            <a:off x="1097280" y="4495800"/>
-            <a:ext cx="10545775" cy="457200"/>
-          </a:xfrm>
-          <a:prstGeom prst="rect">
-            <a:avLst/>
-          </a:prstGeom>
-          <a:noFill/>
-        </p:spPr>
-        <p:txBody>
-          <a:bodyPr wrap="square" anchor="t" lIns="45720" rIns="45720" tIns="27432" bIns="27432">
-            <a:spAutoFit/>
-          </a:bodyPr>
-          <a:lstStyle/>
-          <a:p>
-            <a:pPr algn="l"/>
-            <a:r>
-              <a:rPr sz="1800" b="1" i="0">
-                <a:solidFill>
-                  <a:srgbClr val="111111"/>
-                </a:solidFill>
-                <a:latin typeface="Calibri"/>
-              </a:rPr>
-              <a:t>7. Test the assistant with a trap</a:t>
-            </a:r>
-          </a:p>
-        </p:txBody>
-      </p:sp>
-      <p:sp>
-        <p:nvSpPr>
-          <p:cNvPr id="15" name="TextBox 14"/>
-          <p:cNvSpPr txBox="1"/>
-          <p:nvPr/>
-        </p:nvSpPr>
-        <p:spPr>
-          <a:xfrm>
-            <a:off x="1097280" y="4907280"/>
-            <a:ext cx="10545775" cy="1127760"/>
-          </a:xfrm>
-          <a:prstGeom prst="rect">
-            <a:avLst/>
-          </a:prstGeom>
-          <a:noFill/>
-        </p:spPr>
-        <p:txBody>
-          <a:bodyPr wrap="square" anchor="t" lIns="45720" rIns="45720" tIns="27432" bIns="27432">
-            <a:spAutoFit/>
-          </a:bodyPr>
-          <a:lstStyle/>
-          <a:p>
-            <a:pPr algn="l"/>
-            <a:r>
-              <a:rPr sz="1500" b="0" i="0">
-                <a:solidFill>
-                  <a:srgbClr val="111111"/>
-                </a:solidFill>
-                <a:latin typeface="Calibri"/>
-              </a:rPr>
-              <a:t>Three questions the documents answer, two they do not. Does it say 'not covered' or invent? Record the results.</a:t>
-            </a:r>
-          </a:p>
-        </p:txBody>
-      </p:sp>
-      <p:sp>
-        <p:nvSpPr>
-          <p:cNvPr id="16" name="Rectangle 15"/>
-          <p:cNvSpPr/>
-          <p:nvPr/>
-        </p:nvSpPr>
-        <p:spPr>
-          <a:xfrm>
-            <a:off x="548640" y="6309360"/>
-            <a:ext cx="11094415" cy="19050"/>
-          </a:xfrm>
-          <a:prstGeom prst="rect">
-            <a:avLst/>
-          </a:prstGeom>
-          <a:solidFill>
-            <a:srgbClr val="DDDDDD"/>
-          </a:solidFill>
-          <a:ln>
-            <a:noFill/>
-          </a:ln>
-          <a:effectLst/>
-        </p:spPr>
-        <p:style>
-          <a:lnRef idx="1">
-            <a:schemeClr val="accent1"/>
-          </a:lnRef>
-          <a:fillRef idx="3">
-            <a:schemeClr val="accent1"/>
-          </a:fillRef>
-          <a:effectRef idx="2">
-            <a:schemeClr val="accent1"/>
-          </a:effectRef>
-          <a:fontRef idx="minor">
-            <a:schemeClr val="lt1"/>
-          </a:fontRef>
-        </p:style>
-        <p:txBody>
-          <a:bodyPr rtlCol="0" anchor="ctr"/>
-          <a:lstStyle/>
-          <a:p>
-            <a:pPr algn="ctr"/>
-          </a:p>
-        </p:txBody>
-      </p:sp>
-      <p:sp>
-        <p:nvSpPr>
-          <p:cNvPr id="17" name="TextBox 16"/>
-          <p:cNvSpPr txBox="1"/>
-          <p:nvPr/>
-        </p:nvSpPr>
-        <p:spPr>
-          <a:xfrm>
-            <a:off x="548640" y="6355080"/>
-            <a:ext cx="9144000" cy="365760"/>
-          </a:xfrm>
-          <a:prstGeom prst="rect">
-            <a:avLst/>
-          </a:prstGeom>
-          <a:noFill/>
-        </p:spPr>
-        <p:txBody>
-          <a:bodyPr wrap="square" anchor="t" lIns="45720" rIns="45720" tIns="27432" bIns="27432">
-            <a:spAutoFit/>
-          </a:bodyPr>
-          <a:lstStyle/>
-          <a:p>
-            <a:pPr algn="l"/>
-            <a:r>
               <a:rPr sz="1000" b="0" i="0">
                 <a:solidFill>
                   <a:srgbClr val="666666"/>
@@ -23469,7 +22829,7 @@
       </p:sp>
       <p:sp>
         <p:nvSpPr>
-          <p:cNvPr id="18" name="TextBox 17"/>
+          <p:cNvPr id="9" name="TextBox 8"/>
           <p:cNvSpPr txBox="1"/>
           <p:nvPr/>
         </p:nvSpPr>
@@ -23550,7 +22910,7 @@
                 </a:solidFill>
                 <a:latin typeface="Calibri"/>
               </a:rPr>
-              <a:t>Trap test: two assistants, same five questions</a:t>
+              <a:t>Lab steps (1 to 4)</a:t>
             </a:r>
           </a:p>
         </p:txBody>
@@ -23645,51 +23005,16 @@
       </p:sp>
       <p:sp>
         <p:nvSpPr>
-          <p:cNvPr id="5" name="TextBox 4"/>
-          <p:cNvSpPr txBox="1"/>
-          <p:nvPr/>
-        </p:nvSpPr>
-        <p:spPr>
-          <a:xfrm>
-            <a:off x="548640" y="1325880"/>
-            <a:ext cx="5318607" cy="457200"/>
-          </a:xfrm>
-          <a:prstGeom prst="rect">
-            <a:avLst/>
-          </a:prstGeom>
-          <a:noFill/>
-        </p:spPr>
-        <p:txBody>
-          <a:bodyPr wrap="square" anchor="t" lIns="45720" rIns="45720" tIns="27432" bIns="27432">
-            <a:spAutoFit/>
-          </a:bodyPr>
-          <a:lstStyle/>
-          <a:p>
-            <a:pPr algn="l"/>
-            <a:r>
-              <a:rPr sz="2000" b="1" i="0">
-                <a:solidFill>
-                  <a:srgbClr val="111111"/>
-                </a:solidFill>
-                <a:latin typeface="Calibri"/>
-              </a:rPr>
-              <a:t>Your own Project (step 6)</a:t>
-            </a:r>
-          </a:p>
-        </p:txBody>
-      </p:sp>
-      <p:sp>
-        <p:nvSpPr>
-          <p:cNvPr id="6" name="Rectangle 5"/>
+          <p:cNvPr id="5" name="Oval 4"/>
           <p:cNvSpPr/>
           <p:nvPr/>
         </p:nvSpPr>
         <p:spPr>
           <a:xfrm>
-            <a:off x="548640" y="1801368"/>
-            <a:ext cx="5318607" cy="25400"/>
-          </a:xfrm>
-          <a:prstGeom prst="rect">
+            <a:off x="548640" y="1399032"/>
+            <a:ext cx="384048" cy="384048"/>
+          </a:xfrm>
+          <a:prstGeom prst="ellipse">
             <a:avLst/>
           </a:prstGeom>
           <a:solidFill>
@@ -23715,94 +23040,32 @@
           </a:fontRef>
         </p:style>
         <p:txBody>
-          <a:bodyPr rtlCol="0" anchor="ctr"/>
+          <a:bodyPr rtlCol="0" anchor="ctr" lIns="0" rIns="0"/>
           <a:lstStyle/>
           <a:p>
             <a:pPr algn="ctr"/>
-          </a:p>
-        </p:txBody>
-      </p:sp>
-      <p:sp>
-        <p:nvSpPr>
-          <p:cNvPr id="7" name="TextBox 6"/>
+            <a:r>
+              <a:rPr sz="1300" b="1">
+                <a:solidFill>
+                  <a:srgbClr val="FFFFFF"/>
+                </a:solidFill>
+                <a:latin typeface="Calibri"/>
+              </a:rPr>
+              <a:t>1</a:t>
+            </a:r>
+          </a:p>
+        </p:txBody>
+      </p:sp>
+      <p:sp>
+        <p:nvSpPr>
+          <p:cNvPr id="6" name="TextBox 5"/>
           <p:cNvSpPr txBox="1"/>
           <p:nvPr/>
         </p:nvSpPr>
         <p:spPr>
           <a:xfrm>
-            <a:off x="548640" y="1920240"/>
-            <a:ext cx="5318607" cy="4297680"/>
-          </a:xfrm>
-          <a:prstGeom prst="rect">
-            <a:avLst/>
-          </a:prstGeom>
-          <a:noFill/>
-        </p:spPr>
-        <p:txBody>
-          <a:bodyPr wrap="square" lIns="45720" rIns="45720">
-            <a:spAutoFit/>
-          </a:bodyPr>
-          <a:lstStyle/>
-          <a:p>
-            <a:pPr>
-              <a:spcAft>
-                <a:spcPts val="1000"/>
-              </a:spcAft>
-            </a:pPr>
-            <a:r>
-              <a:rPr sz="1800">
-                <a:solidFill>
-                  <a:srgbClr val="111111"/>
-                </a:solidFill>
-                <a:latin typeface="Calibri"/>
-              </a:rPr>
-              <a:t>•  ChatGPT Project, Claude Project, Gem or Copilot agent</a:t>
-            </a:r>
-          </a:p>
-          <a:p>
-            <a:pPr>
-              <a:spcAft>
-                <a:spcPts val="1000"/>
-              </a:spcAft>
-            </a:pPr>
-            <a:r>
-              <a:rPr sz="1800">
-                <a:solidFill>
-                  <a:srgbClr val="111111"/>
-                </a:solidFill>
-                <a:latin typeface="Calibri"/>
-              </a:rPr>
-              <a:t>•  Your two public or made-up policy documents uploaded</a:t>
-            </a:r>
-          </a:p>
-          <a:p>
-            <a:pPr>
-              <a:spcAft>
-                <a:spcPts val="1000"/>
-              </a:spcAft>
-            </a:pPr>
-            <a:r>
-              <a:rPr sz="1800">
-                <a:solidFill>
-                  <a:srgbClr val="111111"/>
-                </a:solidFill>
-                <a:latin typeface="Calibri"/>
-              </a:rPr>
-              <a:t>•  The assistant instructions from the next slide</a:t>
-            </a:r>
-          </a:p>
-        </p:txBody>
-      </p:sp>
-      <p:sp>
-        <p:nvSpPr>
-          <p:cNvPr id="8" name="TextBox 7"/>
-          <p:cNvSpPr txBox="1"/>
-          <p:nvPr/>
-        </p:nvSpPr>
-        <p:spPr>
-          <a:xfrm>
-            <a:off x="6324447" y="1325880"/>
-            <a:ext cx="5318607" cy="457200"/>
+            <a:off x="1097280" y="1325880"/>
+            <a:ext cx="10545775" cy="457200"/>
           </a:xfrm>
           <a:prstGeom prst="rect">
             <a:avLst/>
@@ -23817,71 +23080,27 @@
           <a:p>
             <a:pPr algn="l"/>
             <a:r>
-              <a:rPr sz="2000" b="1" i="0">
+              <a:rPr sz="1800" b="1" i="0">
                 <a:solidFill>
                   <a:srgbClr val="111111"/>
                 </a:solidFill>
                 <a:latin typeface="Calibri"/>
               </a:rPr>
-              <a:t>The course policy bot @aicaravan_policy_bot</a:t>
-            </a:r>
-          </a:p>
-        </p:txBody>
-      </p:sp>
-      <p:sp>
-        <p:nvSpPr>
-          <p:cNvPr id="9" name="Rectangle 8"/>
-          <p:cNvSpPr/>
-          <p:nvPr/>
-        </p:nvSpPr>
-        <p:spPr>
-          <a:xfrm>
-            <a:off x="6324447" y="1801368"/>
-            <a:ext cx="5318607" cy="25400"/>
-          </a:xfrm>
-          <a:prstGeom prst="rect">
-            <a:avLst/>
-          </a:prstGeom>
-          <a:solidFill>
-            <a:srgbClr val="666666"/>
-          </a:solidFill>
-          <a:ln>
-            <a:noFill/>
-          </a:ln>
-          <a:effectLst/>
-        </p:spPr>
-        <p:style>
-          <a:lnRef idx="1">
-            <a:schemeClr val="accent1"/>
-          </a:lnRef>
-          <a:fillRef idx="3">
-            <a:schemeClr val="accent1"/>
-          </a:fillRef>
-          <a:effectRef idx="2">
-            <a:schemeClr val="accent1"/>
-          </a:effectRef>
-          <a:fontRef idx="minor">
-            <a:schemeClr val="lt1"/>
-          </a:fontRef>
-        </p:style>
-        <p:txBody>
-          <a:bodyPr rtlCol="0" anchor="ctr"/>
-          <a:lstStyle/>
-          <a:p>
-            <a:pPr algn="ctr"/>
-          </a:p>
-        </p:txBody>
-      </p:sp>
-      <p:sp>
-        <p:nvSpPr>
-          <p:cNvPr id="10" name="TextBox 9"/>
+              <a:t>1. Create the library document</a:t>
+            </a:r>
+          </a:p>
+        </p:txBody>
+      </p:sp>
+      <p:sp>
+        <p:nvSpPr>
+          <p:cNvPr id="7" name="TextBox 6"/>
           <p:cNvSpPr txBox="1"/>
           <p:nvPr/>
         </p:nvSpPr>
         <p:spPr>
           <a:xfrm>
-            <a:off x="6324447" y="1920240"/>
-            <a:ext cx="5318607" cy="4297680"/>
+            <a:off x="1097280" y="1737360"/>
+            <a:ext cx="10545775" cy="731520"/>
           </a:xfrm>
           <a:prstGeom prst="rect">
             <a:avLst/>
@@ -23889,86 +23108,34 @@
           <a:noFill/>
         </p:spPr>
         <p:txBody>
-          <a:bodyPr wrap="square" lIns="45720" rIns="45720">
+          <a:bodyPr wrap="square" anchor="t" lIns="45720" rIns="45720" tIns="27432" bIns="27432">
             <a:spAutoFit/>
           </a:bodyPr>
           <a:lstStyle/>
           <a:p>
-            <a:pPr>
-              <a:spcAft>
-                <a:spcPts val="1000"/>
-              </a:spcAft>
-            </a:pPr>
-            <a:r>
-              <a:rPr sz="1800">
+            <a:pPr algn="l"/>
+            <a:r>
+              <a:rPr sz="1500" b="0" i="0">
                 <a:solidFill>
                   <a:srgbClr val="111111"/>
                 </a:solidFill>
                 <a:latin typeface="Calibri"/>
               </a:rPr>
-              <a:t>•  Same instructions, two fictional AI Caravan Ltd. policies built in</a:t>
-            </a:r>
-          </a:p>
-          <a:p>
-            <a:pPr>
-              <a:spcAft>
-                <a:spcPts val="1000"/>
-              </a:spcAft>
-            </a:pPr>
-            <a:r>
-              <a:rPr sz="1800">
-                <a:solidFill>
-                  <a:srgbClr val="111111"/>
-                </a:solidFill>
-                <a:latin typeface="Calibri"/>
-              </a:rPr>
-              <a:t>•  No tools, no memory: it can only answer from the documents</a:t>
-            </a:r>
-          </a:p>
-          <a:p>
-            <a:pPr>
-              <a:spcAft>
-                <a:spcPts val="1000"/>
-              </a:spcAft>
-            </a:pPr>
-            <a:r>
-              <a:rPr sz="1800">
-                <a:solidFill>
-                  <a:srgbClr val="111111"/>
-                </a:solidFill>
-                <a:latin typeface="Calibri"/>
-              </a:rPr>
-              <a:t>•  Ask: annual leave days; carry-over; daily allowance in Jordan (covered)</a:t>
-            </a:r>
-          </a:p>
-          <a:p>
-            <a:pPr>
-              <a:spcAft>
-                <a:spcPts val="1000"/>
-              </a:spcAft>
-            </a:pPr>
-            <a:r>
-              <a:rPr sz="1800">
-                <a:solidFill>
-                  <a:srgbClr val="111111"/>
-                </a:solidFill>
-                <a:latin typeface="Calibri"/>
-              </a:rPr>
-              <a:t>•  Then: parental leave; mileage rate (not covered). Does it admit it?</a:t>
-            </a:r>
-          </a:p>
-        </p:txBody>
-      </p:sp>
-      <p:sp>
-        <p:nvSpPr>
-          <p:cNvPr id="11" name="Rectangle 10"/>
+              <a:t>Name it M2-prompt-library. Five headings: Triage an email, Summarise a meeting transcript, Draft a reply, Extract fields from a form, Classify a request.</a:t>
+            </a:r>
+          </a:p>
+        </p:txBody>
+      </p:sp>
+      <p:sp>
+        <p:nvSpPr>
+          <p:cNvPr id="8" name="Rectangle 7"/>
           <p:cNvSpPr/>
           <p:nvPr/>
         </p:nvSpPr>
         <p:spPr>
           <a:xfrm>
-            <a:off x="548640" y="6309360"/>
-            <a:ext cx="11094415" cy="19050"/>
+            <a:off x="1097280" y="2468880"/>
+            <a:ext cx="10545775" cy="19050"/>
           </a:xfrm>
           <a:prstGeom prst="rect">
             <a:avLst/>
@@ -24005,14 +23172,67 @@
       </p:sp>
       <p:sp>
         <p:nvSpPr>
-          <p:cNvPr id="12" name="TextBox 11"/>
+          <p:cNvPr id="9" name="Oval 8"/>
+          <p:cNvSpPr/>
+          <p:nvPr/>
+        </p:nvSpPr>
+        <p:spPr>
+          <a:xfrm>
+            <a:off x="548640" y="2587752"/>
+            <a:ext cx="384048" cy="384048"/>
+          </a:xfrm>
+          <a:prstGeom prst="ellipse">
+            <a:avLst/>
+          </a:prstGeom>
+          <a:solidFill>
+            <a:srgbClr val="F7A11A"/>
+          </a:solidFill>
+          <a:ln>
+            <a:noFill/>
+          </a:ln>
+          <a:effectLst/>
+        </p:spPr>
+        <p:style>
+          <a:lnRef idx="1">
+            <a:schemeClr val="accent1"/>
+          </a:lnRef>
+          <a:fillRef idx="3">
+            <a:schemeClr val="accent1"/>
+          </a:fillRef>
+          <a:effectRef idx="2">
+            <a:schemeClr val="accent1"/>
+          </a:effectRef>
+          <a:fontRef idx="minor">
+            <a:schemeClr val="lt1"/>
+          </a:fontRef>
+        </p:style>
+        <p:txBody>
+          <a:bodyPr rtlCol="0" anchor="ctr" lIns="0" rIns="0"/>
+          <a:lstStyle/>
+          <a:p>
+            <a:pPr algn="ctr"/>
+            <a:r>
+              <a:rPr sz="1300" b="1">
+                <a:solidFill>
+                  <a:srgbClr val="FFFFFF"/>
+                </a:solidFill>
+                <a:latin typeface="Calibri"/>
+              </a:rPr>
+              <a:t>2</a:t>
+            </a:r>
+          </a:p>
+        </p:txBody>
+      </p:sp>
+      <p:sp>
+        <p:nvSpPr>
+          <p:cNvPr id="10" name="TextBox 9"/>
           <p:cNvSpPr txBox="1"/>
           <p:nvPr/>
         </p:nvSpPr>
         <p:spPr>
           <a:xfrm>
-            <a:off x="548640" y="6355080"/>
-            <a:ext cx="9144000" cy="365760"/>
+            <a:off x="1097280" y="2514600"/>
+            <a:ext cx="10545775" cy="457200"/>
           </a:xfrm>
           <a:prstGeom prst="rect">
             <a:avLst/>
@@ -24027,6 +23247,454 @@
           <a:p>
             <a:pPr algn="l"/>
             <a:r>
+              <a:rPr sz="1800" b="1" i="0">
+                <a:solidFill>
+                  <a:srgbClr val="111111"/>
+                </a:solidFill>
+                <a:latin typeface="Calibri"/>
+              </a:rPr>
+              <a:t>2. Write each template with the five parts</a:t>
+            </a:r>
+          </a:p>
+        </p:txBody>
+      </p:sp>
+      <p:sp>
+        <p:nvSpPr>
+          <p:cNvPr id="11" name="TextBox 10"/>
+          <p:cNvSpPr txBox="1"/>
+          <p:nvPr/>
+        </p:nvSpPr>
+        <p:spPr>
+          <a:xfrm>
+            <a:off x="1097280" y="2926080"/>
+            <a:ext cx="10545775" cy="731520"/>
+          </a:xfrm>
+          <a:prstGeom prst="rect">
+            <a:avLst/>
+          </a:prstGeom>
+          <a:noFill/>
+        </p:spPr>
+        <p:txBody>
+          <a:bodyPr wrap="square" anchor="t" lIns="45720" rIns="45720" tIns="27432" bIns="27432">
+            <a:spAutoFit/>
+          </a:bodyPr>
+          <a:lstStyle/>
+          <a:p>
+            <a:pPr algn="l"/>
+            <a:r>
+              <a:rPr sz="1500" b="0" i="0">
+                <a:solidFill>
+                  <a:srgbClr val="111111"/>
+                </a:solidFill>
+                <a:latin typeface="Calibri"/>
+              </a:rPr>
+              <a:t>Role, context, task, constraints, output format, with [square-bracket] placeholders a colleague can fill in.</a:t>
+            </a:r>
+          </a:p>
+        </p:txBody>
+      </p:sp>
+      <p:sp>
+        <p:nvSpPr>
+          <p:cNvPr id="12" name="Rectangle 11"/>
+          <p:cNvSpPr/>
+          <p:nvPr/>
+        </p:nvSpPr>
+        <p:spPr>
+          <a:xfrm>
+            <a:off x="1097280" y="3657600"/>
+            <a:ext cx="10545775" cy="19050"/>
+          </a:xfrm>
+          <a:prstGeom prst="rect">
+            <a:avLst/>
+          </a:prstGeom>
+          <a:solidFill>
+            <a:srgbClr val="DDDDDD"/>
+          </a:solidFill>
+          <a:ln>
+            <a:noFill/>
+          </a:ln>
+          <a:effectLst/>
+        </p:spPr>
+        <p:style>
+          <a:lnRef idx="1">
+            <a:schemeClr val="accent1"/>
+          </a:lnRef>
+          <a:fillRef idx="3">
+            <a:schemeClr val="accent1"/>
+          </a:fillRef>
+          <a:effectRef idx="2">
+            <a:schemeClr val="accent1"/>
+          </a:effectRef>
+          <a:fontRef idx="minor">
+            <a:schemeClr val="lt1"/>
+          </a:fontRef>
+        </p:style>
+        <p:txBody>
+          <a:bodyPr rtlCol="0" anchor="ctr"/>
+          <a:lstStyle/>
+          <a:p>
+            <a:pPr algn="ctr"/>
+          </a:p>
+        </p:txBody>
+      </p:sp>
+      <p:sp>
+        <p:nvSpPr>
+          <p:cNvPr id="13" name="Oval 12"/>
+          <p:cNvSpPr/>
+          <p:nvPr/>
+        </p:nvSpPr>
+        <p:spPr>
+          <a:xfrm>
+            <a:off x="548640" y="3776472"/>
+            <a:ext cx="384048" cy="384048"/>
+          </a:xfrm>
+          <a:prstGeom prst="ellipse">
+            <a:avLst/>
+          </a:prstGeom>
+          <a:solidFill>
+            <a:srgbClr val="F7A11A"/>
+          </a:solidFill>
+          <a:ln>
+            <a:noFill/>
+          </a:ln>
+          <a:effectLst/>
+        </p:spPr>
+        <p:style>
+          <a:lnRef idx="1">
+            <a:schemeClr val="accent1"/>
+          </a:lnRef>
+          <a:fillRef idx="3">
+            <a:schemeClr val="accent1"/>
+          </a:fillRef>
+          <a:effectRef idx="2">
+            <a:schemeClr val="accent1"/>
+          </a:effectRef>
+          <a:fontRef idx="minor">
+            <a:schemeClr val="lt1"/>
+          </a:fontRef>
+        </p:style>
+        <p:txBody>
+          <a:bodyPr rtlCol="0" anchor="ctr" lIns="0" rIns="0"/>
+          <a:lstStyle/>
+          <a:p>
+            <a:pPr algn="ctr"/>
+            <a:r>
+              <a:rPr sz="1300" b="1">
+                <a:solidFill>
+                  <a:srgbClr val="FFFFFF"/>
+                </a:solidFill>
+                <a:latin typeface="Calibri"/>
+              </a:rPr>
+              <a:t>3</a:t>
+            </a:r>
+          </a:p>
+        </p:txBody>
+      </p:sp>
+      <p:sp>
+        <p:nvSpPr>
+          <p:cNvPr id="14" name="TextBox 13"/>
+          <p:cNvSpPr txBox="1"/>
+          <p:nvPr/>
+        </p:nvSpPr>
+        <p:spPr>
+          <a:xfrm>
+            <a:off x="1097280" y="3703320"/>
+            <a:ext cx="10545775" cy="457200"/>
+          </a:xfrm>
+          <a:prstGeom prst="rect">
+            <a:avLst/>
+          </a:prstGeom>
+          <a:noFill/>
+        </p:spPr>
+        <p:txBody>
+          <a:bodyPr wrap="square" anchor="t" lIns="45720" rIns="45720" tIns="27432" bIns="27432">
+            <a:spAutoFit/>
+          </a:bodyPr>
+          <a:lstStyle/>
+          <a:p>
+            <a:pPr algn="l"/>
+            <a:r>
+              <a:rPr sz="1800" b="1" i="0">
+                <a:solidFill>
+                  <a:srgbClr val="111111"/>
+                </a:solidFill>
+                <a:latin typeface="Calibri"/>
+              </a:rPr>
+              <a:t>3. Add examples to the classifier</a:t>
+            </a:r>
+          </a:p>
+        </p:txBody>
+      </p:sp>
+      <p:sp>
+        <p:nvSpPr>
+          <p:cNvPr id="15" name="TextBox 14"/>
+          <p:cNvSpPr txBox="1"/>
+          <p:nvPr/>
+        </p:nvSpPr>
+        <p:spPr>
+          <a:xfrm>
+            <a:off x="1097280" y="4114800"/>
+            <a:ext cx="10545775" cy="731520"/>
+          </a:xfrm>
+          <a:prstGeom prst="rect">
+            <a:avLst/>
+          </a:prstGeom>
+          <a:noFill/>
+        </p:spPr>
+        <p:txBody>
+          <a:bodyPr wrap="square" anchor="t" lIns="45720" rIns="45720" tIns="27432" bIns="27432">
+            <a:spAutoFit/>
+          </a:bodyPr>
+          <a:lstStyle/>
+          <a:p>
+            <a:pPr algn="l"/>
+            <a:r>
+              <a:rPr sz="1500" b="0" i="0">
+                <a:solidFill>
+                  <a:srgbClr val="111111"/>
+                </a:solidFill>
+                <a:latin typeface="Calibri"/>
+              </a:rPr>
+              <a:t>Four allowed categories, one example each, plus a fifth awkward example that should be 'other'.</a:t>
+            </a:r>
+          </a:p>
+        </p:txBody>
+      </p:sp>
+      <p:sp>
+        <p:nvSpPr>
+          <p:cNvPr id="16" name="Rectangle 15"/>
+          <p:cNvSpPr/>
+          <p:nvPr/>
+        </p:nvSpPr>
+        <p:spPr>
+          <a:xfrm>
+            <a:off x="1097280" y="4846320"/>
+            <a:ext cx="10545775" cy="19050"/>
+          </a:xfrm>
+          <a:prstGeom prst="rect">
+            <a:avLst/>
+          </a:prstGeom>
+          <a:solidFill>
+            <a:srgbClr val="DDDDDD"/>
+          </a:solidFill>
+          <a:ln>
+            <a:noFill/>
+          </a:ln>
+          <a:effectLst/>
+        </p:spPr>
+        <p:style>
+          <a:lnRef idx="1">
+            <a:schemeClr val="accent1"/>
+          </a:lnRef>
+          <a:fillRef idx="3">
+            <a:schemeClr val="accent1"/>
+          </a:fillRef>
+          <a:effectRef idx="2">
+            <a:schemeClr val="accent1"/>
+          </a:effectRef>
+          <a:fontRef idx="minor">
+            <a:schemeClr val="lt1"/>
+          </a:fontRef>
+        </p:style>
+        <p:txBody>
+          <a:bodyPr rtlCol="0" anchor="ctr"/>
+          <a:lstStyle/>
+          <a:p>
+            <a:pPr algn="ctr"/>
+          </a:p>
+        </p:txBody>
+      </p:sp>
+      <p:sp>
+        <p:nvSpPr>
+          <p:cNvPr id="17" name="Oval 16"/>
+          <p:cNvSpPr/>
+          <p:nvPr/>
+        </p:nvSpPr>
+        <p:spPr>
+          <a:xfrm>
+            <a:off x="548640" y="4965192"/>
+            <a:ext cx="384048" cy="384048"/>
+          </a:xfrm>
+          <a:prstGeom prst="ellipse">
+            <a:avLst/>
+          </a:prstGeom>
+          <a:solidFill>
+            <a:srgbClr val="F7A11A"/>
+          </a:solidFill>
+          <a:ln>
+            <a:noFill/>
+          </a:ln>
+          <a:effectLst/>
+        </p:spPr>
+        <p:style>
+          <a:lnRef idx="1">
+            <a:schemeClr val="accent1"/>
+          </a:lnRef>
+          <a:fillRef idx="3">
+            <a:schemeClr val="accent1"/>
+          </a:fillRef>
+          <a:effectRef idx="2">
+            <a:schemeClr val="accent1"/>
+          </a:effectRef>
+          <a:fontRef idx="minor">
+            <a:schemeClr val="lt1"/>
+          </a:fontRef>
+        </p:style>
+        <p:txBody>
+          <a:bodyPr rtlCol="0" anchor="ctr" lIns="0" rIns="0"/>
+          <a:lstStyle/>
+          <a:p>
+            <a:pPr algn="ctr"/>
+            <a:r>
+              <a:rPr sz="1300" b="1">
+                <a:solidFill>
+                  <a:srgbClr val="FFFFFF"/>
+                </a:solidFill>
+                <a:latin typeface="Calibri"/>
+              </a:rPr>
+              <a:t>4</a:t>
+            </a:r>
+          </a:p>
+        </p:txBody>
+      </p:sp>
+      <p:sp>
+        <p:nvSpPr>
+          <p:cNvPr id="18" name="TextBox 17"/>
+          <p:cNvSpPr txBox="1"/>
+          <p:nvPr/>
+        </p:nvSpPr>
+        <p:spPr>
+          <a:xfrm>
+            <a:off x="1097280" y="4892040"/>
+            <a:ext cx="10545775" cy="457200"/>
+          </a:xfrm>
+          <a:prstGeom prst="rect">
+            <a:avLst/>
+          </a:prstGeom>
+          <a:noFill/>
+        </p:spPr>
+        <p:txBody>
+          <a:bodyPr wrap="square" anchor="t" lIns="45720" rIns="45720" tIns="27432" bIns="27432">
+            <a:spAutoFit/>
+          </a:bodyPr>
+          <a:lstStyle/>
+          <a:p>
+            <a:pPr algn="l"/>
+            <a:r>
+              <a:rPr sz="1800" b="1" i="0">
+                <a:solidFill>
+                  <a:srgbClr val="111111"/>
+                </a:solidFill>
+                <a:latin typeface="Calibri"/>
+              </a:rPr>
+              <a:t>4. Build the ten-row test set</a:t>
+            </a:r>
+          </a:p>
+        </p:txBody>
+      </p:sp>
+      <p:sp>
+        <p:nvSpPr>
+          <p:cNvPr id="19" name="TextBox 18"/>
+          <p:cNvSpPr txBox="1"/>
+          <p:nvPr/>
+        </p:nvSpPr>
+        <p:spPr>
+          <a:xfrm>
+            <a:off x="1097280" y="5303520"/>
+            <a:ext cx="10545775" cy="731520"/>
+          </a:xfrm>
+          <a:prstGeom prst="rect">
+            <a:avLst/>
+          </a:prstGeom>
+          <a:noFill/>
+        </p:spPr>
+        <p:txBody>
+          <a:bodyPr wrap="square" anchor="t" lIns="45720" rIns="45720" tIns="27432" bIns="27432">
+            <a:spAutoFit/>
+          </a:bodyPr>
+          <a:lstStyle/>
+          <a:p>
+            <a:pPr algn="l"/>
+            <a:r>
+              <a:rPr sz="1500" b="0" i="0">
+                <a:solidFill>
+                  <a:srgbClr val="111111"/>
+                </a:solidFill>
+                <a:latin typeface="Calibri"/>
+              </a:rPr>
+              <a:t>Ten realistic inputs with the expected category; run the prompt; record the model's answer; count matches.</a:t>
+            </a:r>
+          </a:p>
+        </p:txBody>
+      </p:sp>
+      <p:sp>
+        <p:nvSpPr>
+          <p:cNvPr id="20" name="Rectangle 19"/>
+          <p:cNvSpPr/>
+          <p:nvPr/>
+        </p:nvSpPr>
+        <p:spPr>
+          <a:xfrm>
+            <a:off x="548640" y="6309360"/>
+            <a:ext cx="11094415" cy="19050"/>
+          </a:xfrm>
+          <a:prstGeom prst="rect">
+            <a:avLst/>
+          </a:prstGeom>
+          <a:solidFill>
+            <a:srgbClr val="DDDDDD"/>
+          </a:solidFill>
+          <a:ln>
+            <a:noFill/>
+          </a:ln>
+          <a:effectLst/>
+        </p:spPr>
+        <p:style>
+          <a:lnRef idx="1">
+            <a:schemeClr val="accent1"/>
+          </a:lnRef>
+          <a:fillRef idx="3">
+            <a:schemeClr val="accent1"/>
+          </a:fillRef>
+          <a:effectRef idx="2">
+            <a:schemeClr val="accent1"/>
+          </a:effectRef>
+          <a:fontRef idx="minor">
+            <a:schemeClr val="lt1"/>
+          </a:fontRef>
+        </p:style>
+        <p:txBody>
+          <a:bodyPr rtlCol="0" anchor="ctr"/>
+          <a:lstStyle/>
+          <a:p>
+            <a:pPr algn="ctr"/>
+          </a:p>
+        </p:txBody>
+      </p:sp>
+      <p:sp>
+        <p:nvSpPr>
+          <p:cNvPr id="21" name="TextBox 20"/>
+          <p:cNvSpPr txBox="1"/>
+          <p:nvPr/>
+        </p:nvSpPr>
+        <p:spPr>
+          <a:xfrm>
+            <a:off x="548640" y="6355080"/>
+            <a:ext cx="9144000" cy="365760"/>
+          </a:xfrm>
+          <a:prstGeom prst="rect">
+            <a:avLst/>
+          </a:prstGeom>
+          <a:noFill/>
+        </p:spPr>
+        <p:txBody>
+          <a:bodyPr wrap="square" anchor="t" lIns="45720" rIns="45720" tIns="27432" bIns="27432">
+            <a:spAutoFit/>
+          </a:bodyPr>
+          <a:lstStyle/>
+          <a:p>
+            <a:pPr algn="l"/>
+            <a:r>
               <a:rPr sz="1000" b="0" i="0">
                 <a:solidFill>
                   <a:srgbClr val="666666"/>
@@ -24040,7 +23708,7 @@
       </p:sp>
       <p:sp>
         <p:nvSpPr>
-          <p:cNvPr id="13" name="TextBox 12"/>
+          <p:cNvPr id="22" name="TextBox 21"/>
           <p:cNvSpPr txBox="1"/>
           <p:nvPr/>
         </p:nvSpPr>
@@ -24121,7 +23789,7 @@
                 </a:solidFill>
                 <a:latin typeface="Calibri"/>
               </a:rPr>
-              <a:t>Template skeleton (step 2)</a:t>
+              <a:t>Lab steps (5 to 7)</a:t>
             </a:r>
           </a:p>
         </p:txBody>
@@ -24216,25 +23884,23 @@
       </p:sp>
       <p:sp>
         <p:nvSpPr>
-          <p:cNvPr id="5" name="Rectangle 4"/>
+          <p:cNvPr id="5" name="Oval 4"/>
           <p:cNvSpPr/>
           <p:nvPr/>
         </p:nvSpPr>
         <p:spPr>
           <a:xfrm>
-            <a:off x="548640" y="1371600"/>
-            <a:ext cx="11094415" cy="4663440"/>
-          </a:xfrm>
-          <a:prstGeom prst="rect">
+            <a:off x="548640" y="1399032"/>
+            <a:ext cx="384048" cy="384048"/>
+          </a:xfrm>
+          <a:prstGeom prst="ellipse">
             <a:avLst/>
           </a:prstGeom>
           <a:solidFill>
-            <a:srgbClr val="F2F2F2"/>
+            <a:srgbClr val="F7A11A"/>
           </a:solidFill>
           <a:ln>
-            <a:solidFill>
-              <a:srgbClr val="DDDDDD"/>
-            </a:solidFill>
+            <a:noFill/>
           </a:ln>
           <a:effectLst/>
         </p:spPr>
@@ -24253,10 +23919,19 @@
           </a:fontRef>
         </p:style>
         <p:txBody>
-          <a:bodyPr rtlCol="0" anchor="ctr"/>
+          <a:bodyPr rtlCol="0" anchor="ctr" lIns="0" rIns="0"/>
           <a:lstStyle/>
           <a:p>
             <a:pPr algn="ctr"/>
+            <a:r>
+              <a:rPr sz="1300" b="1">
+                <a:solidFill>
+                  <a:srgbClr val="FFFFFF"/>
+                </a:solidFill>
+                <a:latin typeface="Calibri"/>
+              </a:rPr>
+              <a:t>1</a:t>
+            </a:r>
           </a:p>
         </p:txBody>
       </p:sp>
@@ -24268,8 +23943,8 @@
         </p:nvSpPr>
         <p:spPr>
           <a:xfrm>
-            <a:off x="822960" y="1554480"/>
-            <a:ext cx="10545775" cy="4297680"/>
+            <a:off x="1097280" y="1325880"/>
+            <a:ext cx="10545775" cy="457200"/>
           </a:xfrm>
           <a:prstGeom prst="rect">
             <a:avLst/>
@@ -24284,147 +23959,62 @@
           <a:p>
             <a:pPr algn="l"/>
             <a:r>
-              <a:rPr sz="1600" b="0" i="0">
+              <a:rPr sz="1800" b="1" i="0">
                 <a:solidFill>
                   <a:srgbClr val="111111"/>
                 </a:solidFill>
-                <a:latin typeface="Courier New"/>
-              </a:rPr>
-              <a:t>Role: You are an assistant to the [role] in [department].</a:t>
-            </a:r>
-          </a:p>
+                <a:latin typeface="Calibri"/>
+              </a:rPr>
+              <a:t>5. Fix and re-run</a:t>
+            </a:r>
+          </a:p>
+        </p:txBody>
+      </p:sp>
+      <p:sp>
+        <p:nvSpPr>
+          <p:cNvPr id="7" name="TextBox 6"/>
+          <p:cNvSpPr txBox="1"/>
+          <p:nvPr/>
+        </p:nvSpPr>
+        <p:spPr>
+          <a:xfrm>
+            <a:off x="1097280" y="1737360"/>
+            <a:ext cx="10545775" cy="1127760"/>
+          </a:xfrm>
+          <a:prstGeom prst="rect">
+            <a:avLst/>
+          </a:prstGeom>
+          <a:noFill/>
+        </p:spPr>
+        <p:txBody>
+          <a:bodyPr wrap="square" anchor="t" lIns="45720" rIns="45720" tIns="27432" bIns="27432">
+            <a:spAutoFit/>
+          </a:bodyPr>
+          <a:lstStyle/>
           <a:p>
             <a:pPr algn="l"/>
             <a:r>
-              <a:rPr sz="1600" b="0" i="0">
+              <a:rPr sz="1500" b="0" i="0">
                 <a:solidFill>
                   <a:srgbClr val="111111"/>
                 </a:solidFill>
-                <a:latin typeface="Courier New"/>
-              </a:rPr>
-              <a:t>Context: [two or three facts and definitions the model must know]</a:t>
-            </a:r>
-          </a:p>
-          <a:p>
-            <a:pPr algn="l"/>
-            <a:r>
-              <a:rPr sz="1600" b="0" i="0">
-                <a:solidFill>
-                  <a:srgbClr val="111111"/>
-                </a:solidFill>
-                <a:latin typeface="Courier New"/>
-              </a:rPr>
-              <a:t>Task: [one verb, one deliverable]</a:t>
-            </a:r>
-          </a:p>
-          <a:p>
-            <a:pPr algn="l"/>
-            <a:r>
-              <a:rPr sz="1600" b="0" i="0">
-                <a:solidFill>
-                  <a:srgbClr val="111111"/>
-                </a:solidFill>
-                <a:latin typeface="Courier New"/>
-              </a:rPr>
-              <a:t>Constraints: Use only the information provided. If something is unclear or missing,</a:t>
-            </a:r>
-          </a:p>
-          <a:p>
-            <a:pPr algn="l"/>
-            <a:r>
-              <a:rPr sz="1600" b="0" i="0">
-                <a:solidFill>
-                  <a:srgbClr val="111111"/>
-                </a:solidFill>
-                <a:latin typeface="Courier New"/>
-              </a:rPr>
-              <a:t>write "unclear". Maximum [N] words. Tone: [plain / formal].</a:t>
-            </a:r>
-          </a:p>
-          <a:p>
-            <a:pPr algn="l"/>
-            <a:r>
-              <a:rPr sz="1600" b="0" i="0">
-                <a:solidFill>
-                  <a:srgbClr val="111111"/>
-                </a:solidFill>
-                <a:latin typeface="Courier New"/>
-              </a:rPr>
-              <a:t>Output format (exactly these lines):</a:t>
-            </a:r>
-          </a:p>
-          <a:p>
-            <a:pPr algn="l"/>
-            <a:r>
-              <a:rPr sz="1600" b="0" i="0">
-                <a:solidFill>
-                  <a:srgbClr val="111111"/>
-                </a:solidFill>
-                <a:latin typeface="Courier New"/>
-              </a:rPr>
-              <a:t>[Field 1]:</a:t>
-            </a:r>
-          </a:p>
-          <a:p>
-            <a:pPr algn="l"/>
-            <a:r>
-              <a:rPr sz="1600" b="0" i="0">
-                <a:solidFill>
-                  <a:srgbClr val="111111"/>
-                </a:solidFill>
-                <a:latin typeface="Courier New"/>
-              </a:rPr>
-              <a:t>[Field 2]:</a:t>
-            </a:r>
-          </a:p>
-          <a:p>
-            <a:pPr algn="l"/>
-            <a:r>
-              <a:rPr sz="1600" b="0" i="0">
-                <a:solidFill>
-                  <a:srgbClr val="111111"/>
-                </a:solidFill>
-                <a:latin typeface="Courier New"/>
-              </a:rPr>
-              <a:t>[Field 3]:</a:t>
-            </a:r>
-          </a:p>
-          <a:p>
-            <a:pPr algn="l"/>
-            <a:r>
-              <a:rPr sz="1600" b="0" i="0">
-                <a:solidFill>
-                  <a:srgbClr val="111111"/>
-                </a:solidFill>
-                <a:latin typeface="Courier New"/>
-              </a:rPr>
-              <a:t/>
-            </a:r>
-          </a:p>
-          <a:p>
-            <a:pPr algn="l"/>
-            <a:r>
-              <a:rPr sz="1600" b="0" i="0">
-                <a:solidFill>
-                  <a:srgbClr val="111111"/>
-                </a:solidFill>
-                <a:latin typeface="Courier New"/>
-              </a:rPr>
-              <a:t>Input: [paste text]</a:t>
-            </a:r>
-          </a:p>
-        </p:txBody>
-      </p:sp>
-      <p:sp>
-        <p:nvSpPr>
-          <p:cNvPr id="7" name="Rectangle 6"/>
+                <a:latin typeface="Calibri"/>
+              </a:rPr>
+              <a:t>For every mismatch, change the prompt (a constraint or an example) and run all ten again. Record the second score.</a:t>
+            </a:r>
+          </a:p>
+        </p:txBody>
+      </p:sp>
+      <p:sp>
+        <p:nvSpPr>
+          <p:cNvPr id="8" name="Rectangle 7"/>
           <p:cNvSpPr/>
           <p:nvPr/>
         </p:nvSpPr>
         <p:spPr>
           <a:xfrm>
-            <a:off x="548640" y="6309360"/>
-            <a:ext cx="11094415" cy="19050"/>
+            <a:off x="1097280" y="2865120"/>
+            <a:ext cx="10545775" cy="19050"/>
           </a:xfrm>
           <a:prstGeom prst="rect">
             <a:avLst/>
@@ -24461,14 +24051,67 @@
       </p:sp>
       <p:sp>
         <p:nvSpPr>
-          <p:cNvPr id="8" name="TextBox 7"/>
+          <p:cNvPr id="9" name="Oval 8"/>
+          <p:cNvSpPr/>
+          <p:nvPr/>
+        </p:nvSpPr>
+        <p:spPr>
+          <a:xfrm>
+            <a:off x="548640" y="2983992"/>
+            <a:ext cx="384048" cy="384048"/>
+          </a:xfrm>
+          <a:prstGeom prst="ellipse">
+            <a:avLst/>
+          </a:prstGeom>
+          <a:solidFill>
+            <a:srgbClr val="F7A11A"/>
+          </a:solidFill>
+          <a:ln>
+            <a:noFill/>
+          </a:ln>
+          <a:effectLst/>
+        </p:spPr>
+        <p:style>
+          <a:lnRef idx="1">
+            <a:schemeClr val="accent1"/>
+          </a:lnRef>
+          <a:fillRef idx="3">
+            <a:schemeClr val="accent1"/>
+          </a:fillRef>
+          <a:effectRef idx="2">
+            <a:schemeClr val="accent1"/>
+          </a:effectRef>
+          <a:fontRef idx="minor">
+            <a:schemeClr val="lt1"/>
+          </a:fontRef>
+        </p:style>
+        <p:txBody>
+          <a:bodyPr rtlCol="0" anchor="ctr" lIns="0" rIns="0"/>
+          <a:lstStyle/>
+          <a:p>
+            <a:pPr algn="ctr"/>
+            <a:r>
+              <a:rPr sz="1300" b="1">
+                <a:solidFill>
+                  <a:srgbClr val="FFFFFF"/>
+                </a:solidFill>
+                <a:latin typeface="Calibri"/>
+              </a:rPr>
+              <a:t>2</a:t>
+            </a:r>
+          </a:p>
+        </p:txBody>
+      </p:sp>
+      <p:sp>
+        <p:nvSpPr>
+          <p:cNvPr id="10" name="TextBox 9"/>
           <p:cNvSpPr txBox="1"/>
           <p:nvPr/>
         </p:nvSpPr>
         <p:spPr>
           <a:xfrm>
-            <a:off x="548640" y="6355080"/>
-            <a:ext cx="9144000" cy="365760"/>
+            <a:off x="1097280" y="2910840"/>
+            <a:ext cx="10545775" cy="457200"/>
           </a:xfrm>
           <a:prstGeom prst="rect">
             <a:avLst/>
@@ -24483,6 +24126,287 @@
           <a:p>
             <a:pPr algn="l"/>
             <a:r>
+              <a:rPr sz="1800" b="1" i="0">
+                <a:solidFill>
+                  <a:srgbClr val="111111"/>
+                </a:solidFill>
+                <a:latin typeface="Calibri"/>
+              </a:rPr>
+              <a:t>6. Create the department assistant</a:t>
+            </a:r>
+          </a:p>
+        </p:txBody>
+      </p:sp>
+      <p:sp>
+        <p:nvSpPr>
+          <p:cNvPr id="11" name="TextBox 10"/>
+          <p:cNvSpPr txBox="1"/>
+          <p:nvPr/>
+        </p:nvSpPr>
+        <p:spPr>
+          <a:xfrm>
+            <a:off x="1097280" y="3322320"/>
+            <a:ext cx="10545775" cy="1127760"/>
+          </a:xfrm>
+          <a:prstGeom prst="rect">
+            <a:avLst/>
+          </a:prstGeom>
+          <a:noFill/>
+        </p:spPr>
+        <p:txBody>
+          <a:bodyPr wrap="square" anchor="t" lIns="45720" rIns="45720" tIns="27432" bIns="27432">
+            <a:spAutoFit/>
+          </a:bodyPr>
+          <a:lstStyle/>
+          <a:p>
+            <a:pPr algn="l"/>
+            <a:r>
+              <a:rPr sz="1500" b="0" i="0">
+                <a:solidFill>
+                  <a:srgbClr val="111111"/>
+                </a:solidFill>
+                <a:latin typeface="Calibri"/>
+              </a:rPr>
+              <a:t>A Project, custom GPT, Gem or Copilot agent. Paste the instructions on the next slide; upload two public policy documents.</a:t>
+            </a:r>
+          </a:p>
+        </p:txBody>
+      </p:sp>
+      <p:sp>
+        <p:nvSpPr>
+          <p:cNvPr id="12" name="Rectangle 11"/>
+          <p:cNvSpPr/>
+          <p:nvPr/>
+        </p:nvSpPr>
+        <p:spPr>
+          <a:xfrm>
+            <a:off x="1097280" y="4450080"/>
+            <a:ext cx="10545775" cy="19050"/>
+          </a:xfrm>
+          <a:prstGeom prst="rect">
+            <a:avLst/>
+          </a:prstGeom>
+          <a:solidFill>
+            <a:srgbClr val="DDDDDD"/>
+          </a:solidFill>
+          <a:ln>
+            <a:noFill/>
+          </a:ln>
+          <a:effectLst/>
+        </p:spPr>
+        <p:style>
+          <a:lnRef idx="1">
+            <a:schemeClr val="accent1"/>
+          </a:lnRef>
+          <a:fillRef idx="3">
+            <a:schemeClr val="accent1"/>
+          </a:fillRef>
+          <a:effectRef idx="2">
+            <a:schemeClr val="accent1"/>
+          </a:effectRef>
+          <a:fontRef idx="minor">
+            <a:schemeClr val="lt1"/>
+          </a:fontRef>
+        </p:style>
+        <p:txBody>
+          <a:bodyPr rtlCol="0" anchor="ctr"/>
+          <a:lstStyle/>
+          <a:p>
+            <a:pPr algn="ctr"/>
+          </a:p>
+        </p:txBody>
+      </p:sp>
+      <p:sp>
+        <p:nvSpPr>
+          <p:cNvPr id="13" name="Oval 12"/>
+          <p:cNvSpPr/>
+          <p:nvPr/>
+        </p:nvSpPr>
+        <p:spPr>
+          <a:xfrm>
+            <a:off x="548640" y="4568952"/>
+            <a:ext cx="384048" cy="384048"/>
+          </a:xfrm>
+          <a:prstGeom prst="ellipse">
+            <a:avLst/>
+          </a:prstGeom>
+          <a:solidFill>
+            <a:srgbClr val="F7A11A"/>
+          </a:solidFill>
+          <a:ln>
+            <a:noFill/>
+          </a:ln>
+          <a:effectLst/>
+        </p:spPr>
+        <p:style>
+          <a:lnRef idx="1">
+            <a:schemeClr val="accent1"/>
+          </a:lnRef>
+          <a:fillRef idx="3">
+            <a:schemeClr val="accent1"/>
+          </a:fillRef>
+          <a:effectRef idx="2">
+            <a:schemeClr val="accent1"/>
+          </a:effectRef>
+          <a:fontRef idx="minor">
+            <a:schemeClr val="lt1"/>
+          </a:fontRef>
+        </p:style>
+        <p:txBody>
+          <a:bodyPr rtlCol="0" anchor="ctr" lIns="0" rIns="0"/>
+          <a:lstStyle/>
+          <a:p>
+            <a:pPr algn="ctr"/>
+            <a:r>
+              <a:rPr sz="1300" b="1">
+                <a:solidFill>
+                  <a:srgbClr val="FFFFFF"/>
+                </a:solidFill>
+                <a:latin typeface="Calibri"/>
+              </a:rPr>
+              <a:t>3</a:t>
+            </a:r>
+          </a:p>
+        </p:txBody>
+      </p:sp>
+      <p:sp>
+        <p:nvSpPr>
+          <p:cNvPr id="14" name="TextBox 13"/>
+          <p:cNvSpPr txBox="1"/>
+          <p:nvPr/>
+        </p:nvSpPr>
+        <p:spPr>
+          <a:xfrm>
+            <a:off x="1097280" y="4495800"/>
+            <a:ext cx="10545775" cy="457200"/>
+          </a:xfrm>
+          <a:prstGeom prst="rect">
+            <a:avLst/>
+          </a:prstGeom>
+          <a:noFill/>
+        </p:spPr>
+        <p:txBody>
+          <a:bodyPr wrap="square" anchor="t" lIns="45720" rIns="45720" tIns="27432" bIns="27432">
+            <a:spAutoFit/>
+          </a:bodyPr>
+          <a:lstStyle/>
+          <a:p>
+            <a:pPr algn="l"/>
+            <a:r>
+              <a:rPr sz="1800" b="1" i="0">
+                <a:solidFill>
+                  <a:srgbClr val="111111"/>
+                </a:solidFill>
+                <a:latin typeface="Calibri"/>
+              </a:rPr>
+              <a:t>7. Test the assistant with a trap</a:t>
+            </a:r>
+          </a:p>
+        </p:txBody>
+      </p:sp>
+      <p:sp>
+        <p:nvSpPr>
+          <p:cNvPr id="15" name="TextBox 14"/>
+          <p:cNvSpPr txBox="1"/>
+          <p:nvPr/>
+        </p:nvSpPr>
+        <p:spPr>
+          <a:xfrm>
+            <a:off x="1097280" y="4907280"/>
+            <a:ext cx="10545775" cy="1127760"/>
+          </a:xfrm>
+          <a:prstGeom prst="rect">
+            <a:avLst/>
+          </a:prstGeom>
+          <a:noFill/>
+        </p:spPr>
+        <p:txBody>
+          <a:bodyPr wrap="square" anchor="t" lIns="45720" rIns="45720" tIns="27432" bIns="27432">
+            <a:spAutoFit/>
+          </a:bodyPr>
+          <a:lstStyle/>
+          <a:p>
+            <a:pPr algn="l"/>
+            <a:r>
+              <a:rPr sz="1500" b="0" i="0">
+                <a:solidFill>
+                  <a:srgbClr val="111111"/>
+                </a:solidFill>
+                <a:latin typeface="Calibri"/>
+              </a:rPr>
+              <a:t>Three questions the documents answer, two they do not. Does it say 'not covered' or invent? Record the results.</a:t>
+            </a:r>
+          </a:p>
+        </p:txBody>
+      </p:sp>
+      <p:sp>
+        <p:nvSpPr>
+          <p:cNvPr id="16" name="Rectangle 15"/>
+          <p:cNvSpPr/>
+          <p:nvPr/>
+        </p:nvSpPr>
+        <p:spPr>
+          <a:xfrm>
+            <a:off x="548640" y="6309360"/>
+            <a:ext cx="11094415" cy="19050"/>
+          </a:xfrm>
+          <a:prstGeom prst="rect">
+            <a:avLst/>
+          </a:prstGeom>
+          <a:solidFill>
+            <a:srgbClr val="DDDDDD"/>
+          </a:solidFill>
+          <a:ln>
+            <a:noFill/>
+          </a:ln>
+          <a:effectLst/>
+        </p:spPr>
+        <p:style>
+          <a:lnRef idx="1">
+            <a:schemeClr val="accent1"/>
+          </a:lnRef>
+          <a:fillRef idx="3">
+            <a:schemeClr val="accent1"/>
+          </a:fillRef>
+          <a:effectRef idx="2">
+            <a:schemeClr val="accent1"/>
+          </a:effectRef>
+          <a:fontRef idx="minor">
+            <a:schemeClr val="lt1"/>
+          </a:fontRef>
+        </p:style>
+        <p:txBody>
+          <a:bodyPr rtlCol="0" anchor="ctr"/>
+          <a:lstStyle/>
+          <a:p>
+            <a:pPr algn="ctr"/>
+          </a:p>
+        </p:txBody>
+      </p:sp>
+      <p:sp>
+        <p:nvSpPr>
+          <p:cNvPr id="17" name="TextBox 16"/>
+          <p:cNvSpPr txBox="1"/>
+          <p:nvPr/>
+        </p:nvSpPr>
+        <p:spPr>
+          <a:xfrm>
+            <a:off x="548640" y="6355080"/>
+            <a:ext cx="9144000" cy="365760"/>
+          </a:xfrm>
+          <a:prstGeom prst="rect">
+            <a:avLst/>
+          </a:prstGeom>
+          <a:noFill/>
+        </p:spPr>
+        <p:txBody>
+          <a:bodyPr wrap="square" anchor="t" lIns="45720" rIns="45720" tIns="27432" bIns="27432">
+            <a:spAutoFit/>
+          </a:bodyPr>
+          <a:lstStyle/>
+          <a:p>
+            <a:pPr algn="l"/>
+            <a:r>
               <a:rPr sz="1000" b="0" i="0">
                 <a:solidFill>
                   <a:srgbClr val="666666"/>
@@ -24496,7 +24420,7 @@
       </p:sp>
       <p:sp>
         <p:nvSpPr>
-          <p:cNvPr id="9" name="TextBox 8"/>
+          <p:cNvPr id="18" name="TextBox 17"/>
           <p:cNvSpPr txBox="1"/>
           <p:nvPr/>
         </p:nvSpPr>
@@ -24577,7 +24501,7 @@
                 </a:solidFill>
                 <a:latin typeface="Calibri"/>
               </a:rPr>
-              <a:t>Assistant instructions (step 6)</a:t>
+              <a:t>Trap test: two assistants, same five questions</a:t>
             </a:r>
           </a:p>
         </p:txBody>
@@ -24672,25 +24596,58 @@
       </p:sp>
       <p:sp>
         <p:nvSpPr>
-          <p:cNvPr id="5" name="Rectangle 4"/>
+          <p:cNvPr id="5" name="TextBox 4"/>
+          <p:cNvSpPr txBox="1"/>
+          <p:nvPr/>
+        </p:nvSpPr>
+        <p:spPr>
+          <a:xfrm>
+            <a:off x="548640" y="1325880"/>
+            <a:ext cx="5318607" cy="457200"/>
+          </a:xfrm>
+          <a:prstGeom prst="rect">
+            <a:avLst/>
+          </a:prstGeom>
+          <a:noFill/>
+        </p:spPr>
+        <p:txBody>
+          <a:bodyPr wrap="square" anchor="t" lIns="45720" rIns="45720" tIns="27432" bIns="27432">
+            <a:spAutoFit/>
+          </a:bodyPr>
+          <a:lstStyle/>
+          <a:p>
+            <a:pPr algn="l"/>
+            <a:r>
+              <a:rPr sz="2000" b="1" i="0">
+                <a:solidFill>
+                  <a:srgbClr val="111111"/>
+                </a:solidFill>
+                <a:latin typeface="Calibri"/>
+              </a:rPr>
+              <a:t>Your own Project (step 6)</a:t>
+            </a:r>
+          </a:p>
+        </p:txBody>
+      </p:sp>
+      <p:sp>
+        <p:nvSpPr>
+          <p:cNvPr id="6" name="Rectangle 5"/>
           <p:cNvSpPr/>
           <p:nvPr/>
         </p:nvSpPr>
         <p:spPr>
           <a:xfrm>
-            <a:off x="548640" y="1371600"/>
-            <a:ext cx="11094415" cy="4663440"/>
+            <a:off x="548640" y="1801368"/>
+            <a:ext cx="5318607" cy="25400"/>
           </a:xfrm>
           <a:prstGeom prst="rect">
             <a:avLst/>
           </a:prstGeom>
           <a:solidFill>
-            <a:srgbClr val="F2F2F2"/>
+            <a:srgbClr val="F7A11A"/>
           </a:solidFill>
           <a:ln>
-            <a:solidFill>
-              <a:srgbClr val="DDDDDD"/>
-            </a:solidFill>
+            <a:noFill/>
           </a:ln>
           <a:effectLst/>
         </p:spPr>
@@ -24718,14 +24675,85 @@
       </p:sp>
       <p:sp>
         <p:nvSpPr>
-          <p:cNvPr id="6" name="TextBox 5"/>
+          <p:cNvPr id="7" name="TextBox 6"/>
           <p:cNvSpPr txBox="1"/>
           <p:nvPr/>
         </p:nvSpPr>
         <p:spPr>
           <a:xfrm>
-            <a:off x="822960" y="1554480"/>
-            <a:ext cx="10545775" cy="4297680"/>
+            <a:off x="548640" y="1920240"/>
+            <a:ext cx="5318607" cy="4297680"/>
+          </a:xfrm>
+          <a:prstGeom prst="rect">
+            <a:avLst/>
+          </a:prstGeom>
+          <a:noFill/>
+        </p:spPr>
+        <p:txBody>
+          <a:bodyPr wrap="square" lIns="45720" rIns="45720">
+            <a:spAutoFit/>
+          </a:bodyPr>
+          <a:lstStyle/>
+          <a:p>
+            <a:pPr>
+              <a:spcAft>
+                <a:spcPts val="1000"/>
+              </a:spcAft>
+            </a:pPr>
+            <a:r>
+              <a:rPr sz="1800">
+                <a:solidFill>
+                  <a:srgbClr val="111111"/>
+                </a:solidFill>
+                <a:latin typeface="Calibri"/>
+              </a:rPr>
+              <a:t>•  ChatGPT Project, Claude Project, Gem or Copilot agent</a:t>
+            </a:r>
+          </a:p>
+          <a:p>
+            <a:pPr>
+              <a:spcAft>
+                <a:spcPts val="1000"/>
+              </a:spcAft>
+            </a:pPr>
+            <a:r>
+              <a:rPr sz="1800">
+                <a:solidFill>
+                  <a:srgbClr val="111111"/>
+                </a:solidFill>
+                <a:latin typeface="Calibri"/>
+              </a:rPr>
+              <a:t>•  Your two public or made-up policy documents uploaded</a:t>
+            </a:r>
+          </a:p>
+          <a:p>
+            <a:pPr>
+              <a:spcAft>
+                <a:spcPts val="1000"/>
+              </a:spcAft>
+            </a:pPr>
+            <a:r>
+              <a:rPr sz="1800">
+                <a:solidFill>
+                  <a:srgbClr val="111111"/>
+                </a:solidFill>
+                <a:latin typeface="Calibri"/>
+              </a:rPr>
+              <a:t>•  The assistant instructions from the next slide</a:t>
+            </a:r>
+          </a:p>
+        </p:txBody>
+      </p:sp>
+      <p:sp>
+        <p:nvSpPr>
+          <p:cNvPr id="8" name="TextBox 7"/>
+          <p:cNvSpPr txBox="1"/>
+          <p:nvPr/>
+        </p:nvSpPr>
+        <p:spPr>
+          <a:xfrm>
+            <a:off x="6324447" y="1325880"/>
+            <a:ext cx="5318607" cy="457200"/>
           </a:xfrm>
           <a:prstGeom prst="rect">
             <a:avLst/>
@@ -24740,56 +24768,151 @@
           <a:p>
             <a:pPr algn="l"/>
             <a:r>
-              <a:rPr sz="1600" b="0" i="0">
+              <a:rPr sz="2000" b="1" i="0">
                 <a:solidFill>
                   <a:srgbClr val="111111"/>
                 </a:solidFill>
-                <a:latin typeface="Courier New"/>
-              </a:rPr>
-              <a:t>You are the [department] policy assistant. Answer questions only from the uploaded documents.</a:t>
-            </a:r>
-          </a:p>
-          <a:p>
-            <a:pPr algn="l"/>
-            <a:r>
-              <a:rPr sz="1600" b="0" i="0">
+                <a:latin typeface="Calibri"/>
+              </a:rPr>
+              <a:t>The course policy bot @aicaravan_policy_bot</a:t>
+            </a:r>
+          </a:p>
+        </p:txBody>
+      </p:sp>
+      <p:sp>
+        <p:nvSpPr>
+          <p:cNvPr id="9" name="Rectangle 8"/>
+          <p:cNvSpPr/>
+          <p:nvPr/>
+        </p:nvSpPr>
+        <p:spPr>
+          <a:xfrm>
+            <a:off x="6324447" y="1801368"/>
+            <a:ext cx="5318607" cy="25400"/>
+          </a:xfrm>
+          <a:prstGeom prst="rect">
+            <a:avLst/>
+          </a:prstGeom>
+          <a:solidFill>
+            <a:srgbClr val="666666"/>
+          </a:solidFill>
+          <a:ln>
+            <a:noFill/>
+          </a:ln>
+          <a:effectLst/>
+        </p:spPr>
+        <p:style>
+          <a:lnRef idx="1">
+            <a:schemeClr val="accent1"/>
+          </a:lnRef>
+          <a:fillRef idx="3">
+            <a:schemeClr val="accent1"/>
+          </a:fillRef>
+          <a:effectRef idx="2">
+            <a:schemeClr val="accent1"/>
+          </a:effectRef>
+          <a:fontRef idx="minor">
+            <a:schemeClr val="lt1"/>
+          </a:fontRef>
+        </p:style>
+        <p:txBody>
+          <a:bodyPr rtlCol="0" anchor="ctr"/>
+          <a:lstStyle/>
+          <a:p>
+            <a:pPr algn="ctr"/>
+          </a:p>
+        </p:txBody>
+      </p:sp>
+      <p:sp>
+        <p:nvSpPr>
+          <p:cNvPr id="10" name="TextBox 9"/>
+          <p:cNvSpPr txBox="1"/>
+          <p:nvPr/>
+        </p:nvSpPr>
+        <p:spPr>
+          <a:xfrm>
+            <a:off x="6324447" y="1920240"/>
+            <a:ext cx="5318607" cy="4297680"/>
+          </a:xfrm>
+          <a:prstGeom prst="rect">
+            <a:avLst/>
+          </a:prstGeom>
+          <a:noFill/>
+        </p:spPr>
+        <p:txBody>
+          <a:bodyPr wrap="square" lIns="45720" rIns="45720">
+            <a:spAutoFit/>
+          </a:bodyPr>
+          <a:lstStyle/>
+          <a:p>
+            <a:pPr>
+              <a:spcAft>
+                <a:spcPts val="1000"/>
+              </a:spcAft>
+            </a:pPr>
+            <a:r>
+              <a:rPr sz="1800">
                 <a:solidFill>
                   <a:srgbClr val="111111"/>
                 </a:solidFill>
-                <a:latin typeface="Courier New"/>
-              </a:rPr>
-              <a:t>For every answer, quote the sentence you relied on and name the document.</a:t>
-            </a:r>
-          </a:p>
-          <a:p>
-            <a:pPr algn="l"/>
-            <a:r>
-              <a:rPr sz="1600" b="0" i="0">
+                <a:latin typeface="Calibri"/>
+              </a:rPr>
+              <a:t>•  Same instructions, two fictional AI Caravan Ltd. policies built in</a:t>
+            </a:r>
+          </a:p>
+          <a:p>
+            <a:pPr>
+              <a:spcAft>
+                <a:spcPts val="1000"/>
+              </a:spcAft>
+            </a:pPr>
+            <a:r>
+              <a:rPr sz="1800">
                 <a:solidFill>
                   <a:srgbClr val="111111"/>
                 </a:solidFill>
-                <a:latin typeface="Courier New"/>
-              </a:rPr>
-              <a:t>If the answer is not in the documents, reply: "Not covered by the uploaded policies.</a:t>
-            </a:r>
-          </a:p>
-          <a:p>
-            <a:pPr algn="l"/>
-            <a:r>
-              <a:rPr sz="1600" b="0" i="0">
+                <a:latin typeface="Calibri"/>
+              </a:rPr>
+              <a:t>•  No tools, no memory: it can only answer from the documents</a:t>
+            </a:r>
+          </a:p>
+          <a:p>
+            <a:pPr>
+              <a:spcAft>
+                <a:spcPts val="1000"/>
+              </a:spcAft>
+            </a:pPr>
+            <a:r>
+              <a:rPr sz="1800">
                 <a:solidFill>
                   <a:srgbClr val="111111"/>
                 </a:solidFill>
-                <a:latin typeface="Courier New"/>
-              </a:rPr>
-              <a:t>Please ask [named person]." Keep answers under 120 words.</a:t>
-            </a:r>
-          </a:p>
-        </p:txBody>
-      </p:sp>
-      <p:sp>
-        <p:nvSpPr>
-          <p:cNvPr id="7" name="Rectangle 6"/>
+                <a:latin typeface="Calibri"/>
+              </a:rPr>
+              <a:t>•  Ask: annual leave days; carry-over; daily allowance in Jordan (covered)</a:t>
+            </a:r>
+          </a:p>
+          <a:p>
+            <a:pPr>
+              <a:spcAft>
+                <a:spcPts val="1000"/>
+              </a:spcAft>
+            </a:pPr>
+            <a:r>
+              <a:rPr sz="1800">
+                <a:solidFill>
+                  <a:srgbClr val="111111"/>
+                </a:solidFill>
+                <a:latin typeface="Calibri"/>
+              </a:rPr>
+              <a:t>•  Then: parental leave; mileage rate (not covered). Does it admit it?</a:t>
+            </a:r>
+          </a:p>
+        </p:txBody>
+      </p:sp>
+      <p:sp>
+        <p:nvSpPr>
+          <p:cNvPr id="11" name="Rectangle 10"/>
           <p:cNvSpPr/>
           <p:nvPr/>
         </p:nvSpPr>
@@ -24833,7 +24956,7 @@
       </p:sp>
       <p:sp>
         <p:nvSpPr>
-          <p:cNvPr id="8" name="TextBox 7"/>
+          <p:cNvPr id="12" name="TextBox 11"/>
           <p:cNvSpPr txBox="1"/>
           <p:nvPr/>
         </p:nvSpPr>
@@ -24868,7 +24991,7 @@
       </p:sp>
       <p:sp>
         <p:nvSpPr>
-          <p:cNvPr id="9" name="TextBox 8"/>
+          <p:cNvPr id="13" name="TextBox 12"/>
           <p:cNvSpPr txBox="1"/>
           <p:nvPr/>
         </p:nvSpPr>
@@ -24949,7 +25072,7 @@
                 </a:solidFill>
                 <a:latin typeface="Calibri"/>
               </a:rPr>
-              <a:t>Deliverable</a:t>
+              <a:t>Template skeleton (step 2)</a:t>
             </a:r>
           </a:p>
         </p:txBody>
@@ -25050,17 +25173,19 @@
         </p:nvSpPr>
         <p:spPr>
           <a:xfrm>
-            <a:off x="548640" y="1783080"/>
-            <a:ext cx="76200" cy="2926080"/>
+            <a:off x="548640" y="1371600"/>
+            <a:ext cx="11094415" cy="4663440"/>
           </a:xfrm>
           <a:prstGeom prst="rect">
             <a:avLst/>
           </a:prstGeom>
           <a:solidFill>
-            <a:srgbClr val="F7A11A"/>
+            <a:srgbClr val="F2F2F2"/>
           </a:solidFill>
           <a:ln>
-            <a:noFill/>
+            <a:solidFill>
+              <a:srgbClr val="DDDDDD"/>
+            </a:solidFill>
           </a:ln>
           <a:effectLst/>
         </p:spPr>
@@ -25094,8 +25219,8 @@
         </p:nvSpPr>
         <p:spPr>
           <a:xfrm>
-            <a:off x="914400" y="1783080"/>
-            <a:ext cx="10728655" cy="2926080"/>
+            <a:off x="822960" y="1554480"/>
+            <a:ext cx="10545775" cy="4297680"/>
           </a:xfrm>
           <a:prstGeom prst="rect">
             <a:avLst/>
@@ -25103,20 +25228,140 @@
           <a:noFill/>
         </p:spPr>
         <p:txBody>
-          <a:bodyPr wrap="square" anchor="ctr" lIns="45720" rIns="45720" tIns="27432" bIns="27432">
+          <a:bodyPr wrap="square" anchor="t" lIns="45720" rIns="45720" tIns="27432" bIns="27432">
             <a:spAutoFit/>
           </a:bodyPr>
           <a:lstStyle/>
           <a:p>
             <a:pPr algn="l"/>
             <a:r>
-              <a:rPr sz="2800" b="0" i="0">
+              <a:rPr sz="1600" b="0" i="0">
                 <a:solidFill>
                   <a:srgbClr val="111111"/>
                 </a:solidFill>
-                <a:latin typeface="Calibri"/>
-              </a:rPr>
-              <a:t>The M2-prompt-library document (five templates, test scores before and after, the assistant's trap-test results) plus a screenshot of the assistant answering one question with a quotation. Bring it to the next session.</a:t>
+                <a:latin typeface="Courier New"/>
+              </a:rPr>
+              <a:t>Role: You are an assistant to the [role] in [department].</a:t>
+            </a:r>
+          </a:p>
+          <a:p>
+            <a:pPr algn="l"/>
+            <a:r>
+              <a:rPr sz="1600" b="0" i="0">
+                <a:solidFill>
+                  <a:srgbClr val="111111"/>
+                </a:solidFill>
+                <a:latin typeface="Courier New"/>
+              </a:rPr>
+              <a:t>Context: [two or three facts and definitions the model must know]</a:t>
+            </a:r>
+          </a:p>
+          <a:p>
+            <a:pPr algn="l"/>
+            <a:r>
+              <a:rPr sz="1600" b="0" i="0">
+                <a:solidFill>
+                  <a:srgbClr val="111111"/>
+                </a:solidFill>
+                <a:latin typeface="Courier New"/>
+              </a:rPr>
+              <a:t>Task: [one verb, one deliverable]</a:t>
+            </a:r>
+          </a:p>
+          <a:p>
+            <a:pPr algn="l"/>
+            <a:r>
+              <a:rPr sz="1600" b="0" i="0">
+                <a:solidFill>
+                  <a:srgbClr val="111111"/>
+                </a:solidFill>
+                <a:latin typeface="Courier New"/>
+              </a:rPr>
+              <a:t>Constraints: Use only the information provided. If something is unclear or missing,</a:t>
+            </a:r>
+          </a:p>
+          <a:p>
+            <a:pPr algn="l"/>
+            <a:r>
+              <a:rPr sz="1600" b="0" i="0">
+                <a:solidFill>
+                  <a:srgbClr val="111111"/>
+                </a:solidFill>
+                <a:latin typeface="Courier New"/>
+              </a:rPr>
+              <a:t>write "unclear". Maximum [N] words. Tone: [plain / formal].</a:t>
+            </a:r>
+          </a:p>
+          <a:p>
+            <a:pPr algn="l"/>
+            <a:r>
+              <a:rPr sz="1600" b="0" i="0">
+                <a:solidFill>
+                  <a:srgbClr val="111111"/>
+                </a:solidFill>
+                <a:latin typeface="Courier New"/>
+              </a:rPr>
+              <a:t>Output format (exactly these lines):</a:t>
+            </a:r>
+          </a:p>
+          <a:p>
+            <a:pPr algn="l"/>
+            <a:r>
+              <a:rPr sz="1600" b="0" i="0">
+                <a:solidFill>
+                  <a:srgbClr val="111111"/>
+                </a:solidFill>
+                <a:latin typeface="Courier New"/>
+              </a:rPr>
+              <a:t>[Field 1]:</a:t>
+            </a:r>
+          </a:p>
+          <a:p>
+            <a:pPr algn="l"/>
+            <a:r>
+              <a:rPr sz="1600" b="0" i="0">
+                <a:solidFill>
+                  <a:srgbClr val="111111"/>
+                </a:solidFill>
+                <a:latin typeface="Courier New"/>
+              </a:rPr>
+              <a:t>[Field 2]:</a:t>
+            </a:r>
+          </a:p>
+          <a:p>
+            <a:pPr algn="l"/>
+            <a:r>
+              <a:rPr sz="1600" b="0" i="0">
+                <a:solidFill>
+                  <a:srgbClr val="111111"/>
+                </a:solidFill>
+                <a:latin typeface="Courier New"/>
+              </a:rPr>
+              <a:t>[Field 3]:</a:t>
+            </a:r>
+          </a:p>
+          <a:p>
+            <a:pPr algn="l"/>
+            <a:r>
+              <a:rPr sz="1600" b="0" i="0">
+                <a:solidFill>
+                  <a:srgbClr val="111111"/>
+                </a:solidFill>
+                <a:latin typeface="Courier New"/>
+              </a:rPr>
+              <a:t/>
+            </a:r>
+          </a:p>
+          <a:p>
+            <a:pPr algn="l"/>
+            <a:r>
+              <a:rPr sz="1600" b="0" i="0">
+                <a:solidFill>
+                  <a:srgbClr val="111111"/>
+                </a:solidFill>
+                <a:latin typeface="Courier New"/>
+              </a:rPr>
+              <a:t>Input: [paste text]</a:t>
             </a:r>
           </a:p>
         </p:txBody>
@@ -25261,8 +25506,8 @@
         </p:nvSpPr>
         <p:spPr>
           <a:xfrm>
-            <a:off x="548640" y="2011680"/>
-            <a:ext cx="11094415" cy="457200"/>
+            <a:off x="548640" y="365760"/>
+            <a:ext cx="11094415" cy="777240"/>
           </a:xfrm>
           <a:prstGeom prst="rect">
             <a:avLst/>
@@ -25270,20 +25515,20 @@
           <a:noFill/>
         </p:spPr>
         <p:txBody>
-          <a:bodyPr wrap="square" anchor="t" lIns="45720" rIns="45720" tIns="27432" bIns="27432">
+          <a:bodyPr wrap="square" anchor="b" lIns="45720" rIns="45720" tIns="27432" bIns="27432">
             <a:spAutoFit/>
           </a:bodyPr>
           <a:lstStyle/>
           <a:p>
             <a:pPr algn="l"/>
             <a:r>
-              <a:rPr sz="1400" b="0" i="0">
-                <a:solidFill>
-                  <a:srgbClr val="666666"/>
-                </a:solidFill>
-                <a:latin typeface="Calibri"/>
-              </a:rPr>
-              <a:t>Section · minute 112</a:t>
+              <a:rPr sz="3000" b="1" i="0">
+                <a:solidFill>
+                  <a:srgbClr val="111111"/>
+                </a:solidFill>
+                <a:latin typeface="Calibri"/>
+              </a:rPr>
+              <a:t>Assistant instructions (step 6)</a:t>
             </a:r>
           </a:p>
         </p:txBody>
@@ -25296,8 +25541,8 @@
         </p:nvSpPr>
         <p:spPr>
           <a:xfrm>
-            <a:off x="548640" y="2514600"/>
-            <a:ext cx="1463040" cy="50800"/>
+            <a:off x="548640" y="1115568"/>
+            <a:ext cx="1097280" cy="38100"/>
           </a:xfrm>
           <a:prstGeom prst="rect">
             <a:avLst/>
@@ -25334,143 +25579,14 @@
       </p:sp>
       <p:sp>
         <p:nvSpPr>
-          <p:cNvPr id="4" name="TextBox 3"/>
-          <p:cNvSpPr txBox="1"/>
-          <p:nvPr/>
-        </p:nvSpPr>
-        <p:spPr>
-          <a:xfrm>
-            <a:off x="548640" y="2651760"/>
-            <a:ext cx="11094415" cy="1371600"/>
-          </a:xfrm>
-          <a:prstGeom prst="rect">
-            <a:avLst/>
-          </a:prstGeom>
-          <a:noFill/>
-        </p:spPr>
-        <p:txBody>
-          <a:bodyPr wrap="square" anchor="t" lIns="45720" rIns="45720" tIns="27432" bIns="27432">
-            <a:spAutoFit/>
-          </a:bodyPr>
-          <a:lstStyle/>
-          <a:p>
-            <a:pPr algn="l"/>
-            <a:r>
-              <a:rPr sz="3800" b="1" i="0">
-                <a:solidFill>
-                  <a:srgbClr val="111111"/>
-                </a:solidFill>
-                <a:latin typeface="Calibri"/>
-              </a:rPr>
-              <a:t>Kahoot: knowledge check</a:t>
-            </a:r>
-          </a:p>
-        </p:txBody>
-      </p:sp>
-      <p:sp>
-        <p:nvSpPr>
-          <p:cNvPr id="5" name="TextBox 4"/>
-          <p:cNvSpPr txBox="1"/>
-          <p:nvPr/>
-        </p:nvSpPr>
-        <p:spPr>
-          <a:xfrm>
-            <a:off x="548640" y="4023360"/>
-            <a:ext cx="11094415" cy="822960"/>
-          </a:xfrm>
-          <a:prstGeom prst="rect">
-            <a:avLst/>
-          </a:prstGeom>
-          <a:noFill/>
-        </p:spPr>
-        <p:txBody>
-          <a:bodyPr wrap="square" anchor="t" lIns="45720" rIns="45720" tIns="27432" bIns="27432">
-            <a:spAutoFit/>
-          </a:bodyPr>
-          <a:lstStyle/>
-          <a:p>
-            <a:pPr algn="l"/>
-            <a:r>
-              <a:rPr sz="2000" b="0" i="0">
-                <a:solidFill>
-                  <a:srgbClr val="666666"/>
-                </a:solidFill>
-                <a:latin typeface="Calibri"/>
-              </a:rPr>
-              <a:t>20 questions, 20 seconds each. Phones out.</a:t>
-            </a:r>
-          </a:p>
-        </p:txBody>
-      </p:sp>
-      <p:sp>
-        <p:nvSpPr>
-          <p:cNvPr id="6" name="TextBox 5"/>
-          <p:cNvSpPr txBox="1"/>
-          <p:nvPr/>
-        </p:nvSpPr>
-        <p:spPr>
-          <a:xfrm>
-            <a:off x="548640" y="4846320"/>
-            <a:ext cx="11094415" cy="457200"/>
-          </a:xfrm>
-          <a:prstGeom prst="rect">
-            <a:avLst/>
-          </a:prstGeom>
-          <a:noFill/>
-        </p:spPr>
-        <p:txBody>
-          <a:bodyPr wrap="square" anchor="t" lIns="45720" rIns="45720" tIns="27432" bIns="27432">
-            <a:spAutoFit/>
-          </a:bodyPr>
-          <a:lstStyle/>
-          <a:p>
-            <a:pPr algn="l"/>
-            <a:r>
-              <a:rPr sz="1400" b="0" i="0">
-                <a:solidFill>
-                  <a:srgbClr val="666666"/>
-                </a:solidFill>
-                <a:latin typeface="Calibri"/>
-              </a:rPr>
-              <a:t>About 8 minutes</a:t>
-            </a:r>
-          </a:p>
-        </p:txBody>
-      </p:sp>
-      <p:pic>
-        <p:nvPicPr>
-          <p:cNvPr id="7" name="Picture 6" descr="kahoot_logo.png"/>
-          <p:cNvPicPr>
-            <a:picLocks noChangeAspect="1"/>
-          </p:cNvPicPr>
-          <p:nvPr/>
-        </p:nvPicPr>
-        <p:blipFill>
-          <a:blip r:embed="rId2"/>
-          <a:stretch>
-            <a:fillRect/>
-          </a:stretch>
-        </p:blipFill>
-        <p:spPr>
-          <a:xfrm>
-            <a:off x="6888175" y="2206219"/>
-            <a:ext cx="4754880" cy="1622602"/>
-          </a:xfrm>
-          <a:prstGeom prst="rect">
-            <a:avLst/>
-          </a:prstGeom>
-        </p:spPr>
-      </p:pic>
-      <p:sp>
-        <p:nvSpPr>
-          <p:cNvPr id="8" name="Rectangle 7"/>
+          <p:cNvPr id="4" name="Rectangle 3"/>
           <p:cNvSpPr/>
           <p:nvPr/>
         </p:nvSpPr>
         <p:spPr>
           <a:xfrm>
-            <a:off x="548640" y="6309360"/>
-            <a:ext cx="11094415" cy="19050"/>
+            <a:off x="1645920" y="1115568"/>
+            <a:ext cx="9997135" cy="19050"/>
           </a:xfrm>
           <a:prstGeom prst="rect">
             <a:avLst/>
@@ -25507,14 +25623,60 @@
       </p:sp>
       <p:sp>
         <p:nvSpPr>
-          <p:cNvPr id="9" name="TextBox 8"/>
+          <p:cNvPr id="5" name="Rectangle 4"/>
+          <p:cNvSpPr/>
+          <p:nvPr/>
+        </p:nvSpPr>
+        <p:spPr>
+          <a:xfrm>
+            <a:off x="548640" y="1371600"/>
+            <a:ext cx="11094415" cy="4663440"/>
+          </a:xfrm>
+          <a:prstGeom prst="rect">
+            <a:avLst/>
+          </a:prstGeom>
+          <a:solidFill>
+            <a:srgbClr val="F2F2F2"/>
+          </a:solidFill>
+          <a:ln>
+            <a:solidFill>
+              <a:srgbClr val="DDDDDD"/>
+            </a:solidFill>
+          </a:ln>
+          <a:effectLst/>
+        </p:spPr>
+        <p:style>
+          <a:lnRef idx="1">
+            <a:schemeClr val="accent1"/>
+          </a:lnRef>
+          <a:fillRef idx="3">
+            <a:schemeClr val="accent1"/>
+          </a:fillRef>
+          <a:effectRef idx="2">
+            <a:schemeClr val="accent1"/>
+          </a:effectRef>
+          <a:fontRef idx="minor">
+            <a:schemeClr val="lt1"/>
+          </a:fontRef>
+        </p:style>
+        <p:txBody>
+          <a:bodyPr rtlCol="0" anchor="ctr"/>
+          <a:lstStyle/>
+          <a:p>
+            <a:pPr algn="ctr"/>
+          </a:p>
+        </p:txBody>
+      </p:sp>
+      <p:sp>
+        <p:nvSpPr>
+          <p:cNvPr id="6" name="TextBox 5"/>
           <p:cNvSpPr txBox="1"/>
           <p:nvPr/>
         </p:nvSpPr>
         <p:spPr>
           <a:xfrm>
-            <a:off x="548640" y="6355080"/>
-            <a:ext cx="9144000" cy="365760"/>
+            <a:off x="822960" y="1554480"/>
+            <a:ext cx="10545775" cy="4297680"/>
           </a:xfrm>
           <a:prstGeom prst="rect">
             <a:avLst/>
@@ -25529,6 +25691,121 @@
           <a:p>
             <a:pPr algn="l"/>
             <a:r>
+              <a:rPr sz="1600" b="0" i="0">
+                <a:solidFill>
+                  <a:srgbClr val="111111"/>
+                </a:solidFill>
+                <a:latin typeface="Courier New"/>
+              </a:rPr>
+              <a:t>You are the [department] policy assistant. Answer questions only from the uploaded documents.</a:t>
+            </a:r>
+          </a:p>
+          <a:p>
+            <a:pPr algn="l"/>
+            <a:r>
+              <a:rPr sz="1600" b="0" i="0">
+                <a:solidFill>
+                  <a:srgbClr val="111111"/>
+                </a:solidFill>
+                <a:latin typeface="Courier New"/>
+              </a:rPr>
+              <a:t>For every answer, quote the sentence you relied on and name the document.</a:t>
+            </a:r>
+          </a:p>
+          <a:p>
+            <a:pPr algn="l"/>
+            <a:r>
+              <a:rPr sz="1600" b="0" i="0">
+                <a:solidFill>
+                  <a:srgbClr val="111111"/>
+                </a:solidFill>
+                <a:latin typeface="Courier New"/>
+              </a:rPr>
+              <a:t>If the answer is not in the documents, reply: "Not covered by the uploaded policies.</a:t>
+            </a:r>
+          </a:p>
+          <a:p>
+            <a:pPr algn="l"/>
+            <a:r>
+              <a:rPr sz="1600" b="0" i="0">
+                <a:solidFill>
+                  <a:srgbClr val="111111"/>
+                </a:solidFill>
+                <a:latin typeface="Courier New"/>
+              </a:rPr>
+              <a:t>Please ask [named person]." Keep answers under 120 words.</a:t>
+            </a:r>
+          </a:p>
+        </p:txBody>
+      </p:sp>
+      <p:sp>
+        <p:nvSpPr>
+          <p:cNvPr id="7" name="Rectangle 6"/>
+          <p:cNvSpPr/>
+          <p:nvPr/>
+        </p:nvSpPr>
+        <p:spPr>
+          <a:xfrm>
+            <a:off x="548640" y="6309360"/>
+            <a:ext cx="11094415" cy="19050"/>
+          </a:xfrm>
+          <a:prstGeom prst="rect">
+            <a:avLst/>
+          </a:prstGeom>
+          <a:solidFill>
+            <a:srgbClr val="DDDDDD"/>
+          </a:solidFill>
+          <a:ln>
+            <a:noFill/>
+          </a:ln>
+          <a:effectLst/>
+        </p:spPr>
+        <p:style>
+          <a:lnRef idx="1">
+            <a:schemeClr val="accent1"/>
+          </a:lnRef>
+          <a:fillRef idx="3">
+            <a:schemeClr val="accent1"/>
+          </a:fillRef>
+          <a:effectRef idx="2">
+            <a:schemeClr val="accent1"/>
+          </a:effectRef>
+          <a:fontRef idx="minor">
+            <a:schemeClr val="lt1"/>
+          </a:fontRef>
+        </p:style>
+        <p:txBody>
+          <a:bodyPr rtlCol="0" anchor="ctr"/>
+          <a:lstStyle/>
+          <a:p>
+            <a:pPr algn="ctr"/>
+          </a:p>
+        </p:txBody>
+      </p:sp>
+      <p:sp>
+        <p:nvSpPr>
+          <p:cNvPr id="8" name="TextBox 7"/>
+          <p:cNvSpPr txBox="1"/>
+          <p:nvPr/>
+        </p:nvSpPr>
+        <p:spPr>
+          <a:xfrm>
+            <a:off x="548640" y="6355080"/>
+            <a:ext cx="9144000" cy="365760"/>
+          </a:xfrm>
+          <a:prstGeom prst="rect">
+            <a:avLst/>
+          </a:prstGeom>
+          <a:noFill/>
+        </p:spPr>
+        <p:txBody>
+          <a:bodyPr wrap="square" anchor="t" lIns="45720" rIns="45720" tIns="27432" bIns="27432">
+            <a:spAutoFit/>
+          </a:bodyPr>
+          <a:lstStyle/>
+          <a:p>
+            <a:pPr algn="l"/>
+            <a:r>
               <a:rPr sz="1000" b="0" i="0">
                 <a:solidFill>
                   <a:srgbClr val="666666"/>
@@ -25542,7 +25819,7 @@
       </p:sp>
       <p:sp>
         <p:nvSpPr>
-          <p:cNvPr id="10" name="TextBox 9"/>
+          <p:cNvPr id="9" name="TextBox 8"/>
           <p:cNvSpPr txBox="1"/>
           <p:nvPr/>
         </p:nvSpPr>
@@ -25623,7 +25900,7 @@
                 </a:solidFill>
                 <a:latin typeface="Calibri"/>
               </a:rPr>
-              <a:t>Join the Kahoot</a:t>
+              <a:t>Deliverable</a:t>
             </a:r>
           </a:p>
         </p:txBody>
@@ -25716,75 +25993,16 @@
           </a:p>
         </p:txBody>
       </p:sp>
-      <p:pic>
-        <p:nvPicPr>
-          <p:cNvPr id="5" name="Picture 4" descr="kahoot_logo.png"/>
-          <p:cNvPicPr>
-            <a:picLocks noChangeAspect="1"/>
-          </p:cNvPicPr>
-          <p:nvPr/>
-        </p:nvPicPr>
-        <p:blipFill>
-          <a:blip r:embed="rId2"/>
-          <a:stretch>
-            <a:fillRect/>
-          </a:stretch>
-        </p:blipFill>
-        <p:spPr>
-          <a:xfrm>
-            <a:off x="9315522" y="274320"/>
-            <a:ext cx="2277626" cy="777240"/>
-          </a:xfrm>
-          <a:prstGeom prst="rect">
-            <a:avLst/>
-          </a:prstGeom>
-        </p:spPr>
-      </p:pic>
-      <p:sp>
-        <p:nvSpPr>
-          <p:cNvPr id="6" name="TextBox 5"/>
-          <p:cNvSpPr txBox="1"/>
-          <p:nvPr/>
-        </p:nvSpPr>
-        <p:spPr>
-          <a:xfrm>
-            <a:off x="548640" y="1325880"/>
-            <a:ext cx="5318607" cy="457200"/>
-          </a:xfrm>
-          <a:prstGeom prst="rect">
-            <a:avLst/>
-          </a:prstGeom>
-          <a:noFill/>
-        </p:spPr>
-        <p:txBody>
-          <a:bodyPr wrap="square" anchor="t" lIns="45720" rIns="45720" tIns="27432" bIns="27432">
-            <a:spAutoFit/>
-          </a:bodyPr>
-          <a:lstStyle/>
-          <a:p>
-            <a:pPr algn="l"/>
-            <a:r>
-              <a:rPr sz="2000" b="1" i="0">
-                <a:solidFill>
-                  <a:srgbClr val="111111"/>
-                </a:solidFill>
-                <a:latin typeface="Calibri"/>
-              </a:rPr>
-              <a:t>How to join</a:t>
-            </a:r>
-          </a:p>
-        </p:txBody>
-      </p:sp>
-      <p:sp>
-        <p:nvSpPr>
-          <p:cNvPr id="7" name="Rectangle 6"/>
+      <p:sp>
+        <p:nvSpPr>
+          <p:cNvPr id="5" name="Rectangle 4"/>
           <p:cNvSpPr/>
           <p:nvPr/>
         </p:nvSpPr>
         <p:spPr>
           <a:xfrm>
-            <a:off x="548640" y="1801368"/>
-            <a:ext cx="5318607" cy="25400"/>
+            <a:off x="548640" y="1783080"/>
+            <a:ext cx="76200" cy="2926080"/>
           </a:xfrm>
           <a:prstGeom prst="rect">
             <a:avLst/>
@@ -25821,14 +26039,14 @@
       </p:sp>
       <p:sp>
         <p:nvSpPr>
-          <p:cNvPr id="8" name="TextBox 7"/>
+          <p:cNvPr id="6" name="TextBox 5"/>
           <p:cNvSpPr txBox="1"/>
           <p:nvPr/>
         </p:nvSpPr>
         <p:spPr>
           <a:xfrm>
-            <a:off x="548640" y="1920240"/>
-            <a:ext cx="5318607" cy="4297680"/>
+            <a:off x="914400" y="1783080"/>
+            <a:ext cx="10728655" cy="2926080"/>
           </a:xfrm>
           <a:prstGeom prst="rect">
             <a:avLst/>
@@ -25836,245 +26054,27 @@
           <a:noFill/>
         </p:spPr>
         <p:txBody>
-          <a:bodyPr wrap="square" lIns="45720" rIns="45720">
+          <a:bodyPr wrap="square" anchor="ctr" lIns="45720" rIns="45720" tIns="27432" bIns="27432">
             <a:spAutoFit/>
           </a:bodyPr>
           <a:lstStyle/>
           <a:p>
-            <a:pPr>
-              <a:spcAft>
-                <a:spcPts val="1000"/>
-              </a:spcAft>
-            </a:pPr>
-            <a:r>
-              <a:rPr sz="1800">
+            <a:pPr algn="l"/>
+            <a:r>
+              <a:rPr sz="2800" b="0" i="0">
                 <a:solidFill>
                   <a:srgbClr val="111111"/>
                 </a:solidFill>
                 <a:latin typeface="Calibri"/>
               </a:rPr>
-              <a:t>•  Open kahoot.it on your phone, or the Kahoot app</a:t>
-            </a:r>
-          </a:p>
-          <a:p>
-            <a:pPr>
-              <a:spcAft>
-                <a:spcPts val="1000"/>
-              </a:spcAft>
-            </a:pPr>
-            <a:r>
-              <a:rPr sz="1800">
-                <a:solidFill>
-                  <a:srgbClr val="111111"/>
-                </a:solidFill>
-                <a:latin typeface="Calibri"/>
-              </a:rPr>
-              <a:t>•  Enter the game PIN shown on the screen</a:t>
-            </a:r>
-          </a:p>
-          <a:p>
-            <a:pPr>
-              <a:spcAft>
-                <a:spcPts val="1000"/>
-              </a:spcAft>
-            </a:pPr>
-            <a:r>
-              <a:rPr sz="1800">
-                <a:solidFill>
-                  <a:srgbClr val="111111"/>
-                </a:solidFill>
-                <a:latin typeface="Calibri"/>
-              </a:rPr>
-              <a:t>•  Nickname: your first name</a:t>
-            </a:r>
-          </a:p>
-          <a:p>
-            <a:pPr>
-              <a:spcAft>
-                <a:spcPts val="1000"/>
-              </a:spcAft>
-            </a:pPr>
-            <a:r>
-              <a:rPr sz="1800">
-                <a:solidFill>
-                  <a:srgbClr val="111111"/>
-                </a:solidFill>
-                <a:latin typeface="Calibri"/>
-              </a:rPr>
-              <a:t>•  20 seconds per question; answer on your phone</a:t>
-            </a:r>
-          </a:p>
-        </p:txBody>
-      </p:sp>
-      <p:sp>
-        <p:nvSpPr>
-          <p:cNvPr id="9" name="TextBox 8"/>
-          <p:cNvSpPr txBox="1"/>
-          <p:nvPr/>
-        </p:nvSpPr>
-        <p:spPr>
-          <a:xfrm>
-            <a:off x="6324447" y="1325880"/>
-            <a:ext cx="5318607" cy="457200"/>
-          </a:xfrm>
-          <a:prstGeom prst="rect">
-            <a:avLst/>
-          </a:prstGeom>
-          <a:noFill/>
-        </p:spPr>
-        <p:txBody>
-          <a:bodyPr wrap="square" anchor="t" lIns="45720" rIns="45720" tIns="27432" bIns="27432">
-            <a:spAutoFit/>
-          </a:bodyPr>
-          <a:lstStyle/>
-          <a:p>
-            <a:pPr algn="l"/>
-            <a:r>
-              <a:rPr sz="2000" b="1" i="0">
-                <a:solidFill>
-                  <a:srgbClr val="111111"/>
-                </a:solidFill>
-                <a:latin typeface="Calibri"/>
-              </a:rPr>
-              <a:t>Fair play notes</a:t>
-            </a:r>
-          </a:p>
-        </p:txBody>
-      </p:sp>
-      <p:sp>
-        <p:nvSpPr>
-          <p:cNvPr id="10" name="Rectangle 9"/>
-          <p:cNvSpPr/>
-          <p:nvPr/>
-        </p:nvSpPr>
-        <p:spPr>
-          <a:xfrm>
-            <a:off x="6324447" y="1801368"/>
-            <a:ext cx="5318607" cy="25400"/>
-          </a:xfrm>
-          <a:prstGeom prst="rect">
-            <a:avLst/>
-          </a:prstGeom>
-          <a:solidFill>
-            <a:srgbClr val="666666"/>
-          </a:solidFill>
-          <a:ln>
-            <a:noFill/>
-          </a:ln>
-          <a:effectLst/>
-        </p:spPr>
-        <p:style>
-          <a:lnRef idx="1">
-            <a:schemeClr val="accent1"/>
-          </a:lnRef>
-          <a:fillRef idx="3">
-            <a:schemeClr val="accent1"/>
-          </a:fillRef>
-          <a:effectRef idx="2">
-            <a:schemeClr val="accent1"/>
-          </a:effectRef>
-          <a:fontRef idx="minor">
-            <a:schemeClr val="lt1"/>
-          </a:fontRef>
-        </p:style>
-        <p:txBody>
-          <a:bodyPr rtlCol="0" anchor="ctr"/>
-          <a:lstStyle/>
-          <a:p>
-            <a:pPr algn="ctr"/>
-          </a:p>
-        </p:txBody>
-      </p:sp>
-      <p:sp>
-        <p:nvSpPr>
-          <p:cNvPr id="11" name="TextBox 10"/>
-          <p:cNvSpPr txBox="1"/>
-          <p:nvPr/>
-        </p:nvSpPr>
-        <p:spPr>
-          <a:xfrm>
-            <a:off x="6324447" y="1920240"/>
-            <a:ext cx="5318607" cy="4297680"/>
-          </a:xfrm>
-          <a:prstGeom prst="rect">
-            <a:avLst/>
-          </a:prstGeom>
-          <a:noFill/>
-        </p:spPr>
-        <p:txBody>
-          <a:bodyPr wrap="square" lIns="45720" rIns="45720">
-            <a:spAutoFit/>
-          </a:bodyPr>
-          <a:lstStyle/>
-          <a:p>
-            <a:pPr>
-              <a:spcAft>
-                <a:spcPts val="1000"/>
-              </a:spcAft>
-            </a:pPr>
-            <a:r>
-              <a:rPr sz="1800">
-                <a:solidFill>
-                  <a:srgbClr val="111111"/>
-                </a:solidFill>
-                <a:latin typeface="Calibri"/>
-              </a:rPr>
-              <a:t>•  All four answers are about the same length. The long one is not a hint.</a:t>
-            </a:r>
-          </a:p>
-          <a:p>
-            <a:pPr>
-              <a:spcAft>
-                <a:spcPts val="1000"/>
-              </a:spcAft>
-            </a:pPr>
-            <a:r>
-              <a:rPr sz="1800">
-                <a:solidFill>
-                  <a:srgbClr val="111111"/>
-                </a:solidFill>
-                <a:latin typeface="Calibri"/>
-              </a:rPr>
-              <a:t>•  Correct answers are spread evenly over the four colours.</a:t>
-            </a:r>
-          </a:p>
-          <a:p>
-            <a:pPr>
-              <a:spcAft>
-                <a:spcPts val="1000"/>
-              </a:spcAft>
-            </a:pPr>
-            <a:r>
-              <a:rPr sz="1800">
-                <a:solidFill>
-                  <a:srgbClr val="111111"/>
-                </a:solidFill>
-                <a:latin typeface="Calibri"/>
-              </a:rPr>
-              <a:t>•  We run as many as time allows in the room</a:t>
-            </a:r>
-          </a:p>
-          <a:p>
-            <a:pPr>
-              <a:spcAft>
-                <a:spcPts val="1000"/>
-              </a:spcAft>
-            </a:pPr>
-            <a:r>
-              <a:rPr sz="1800">
-                <a:solidFill>
-                  <a:srgbClr val="111111"/>
-                </a:solidFill>
-                <a:latin typeface="Calibri"/>
-              </a:rPr>
-              <a:t>•  The rest arrive as a Kahoot challenge link for homework</a:t>
-            </a:r>
-          </a:p>
-        </p:txBody>
-      </p:sp>
-      <p:sp>
-        <p:nvSpPr>
-          <p:cNvPr id="12" name="Rectangle 11"/>
+              <a:t>The M2-prompt-library document (five templates, test scores before and after, the assistant's trap-test results) plus a screenshot of the assistant answering one question with a quotation. Bring it to the next session.</a:t>
+            </a:r>
+          </a:p>
+        </p:txBody>
+      </p:sp>
+      <p:sp>
+        <p:nvSpPr>
+          <p:cNvPr id="7" name="Rectangle 6"/>
           <p:cNvSpPr/>
           <p:nvPr/>
         </p:nvSpPr>
@@ -26118,7 +26118,7 @@
       </p:sp>
       <p:sp>
         <p:nvSpPr>
-          <p:cNvPr id="13" name="TextBox 12"/>
+          <p:cNvPr id="8" name="TextBox 7"/>
           <p:cNvSpPr txBox="1"/>
           <p:nvPr/>
         </p:nvSpPr>
@@ -26153,7 +26153,7 @@
       </p:sp>
       <p:sp>
         <p:nvSpPr>
-          <p:cNvPr id="14" name="TextBox 13"/>
+          <p:cNvPr id="9" name="TextBox 8"/>
           <p:cNvSpPr txBox="1"/>
           <p:nvPr/>
         </p:nvSpPr>

</xml_diff>